<commit_message>
vault backup: 2026-08-06 14:36:24
</commit_message>
<xml_diff>
--- a/项目/学习/多任务成像/相关论文/四篇生成模型组会汇报_优化版.pptx
+++ b/项目/学习/多任务成像/相关论文/四篇生成模型组会汇报_优化版.pptx
@@ -5,7 +5,7 @@
     <p:sldMasterId id="2147483648" r:id="rId1"/>
   </p:sldMasterIdLst>
   <p:notesMasterIdLst>
-    <p:notesMasterId r:id="rId10"/>
+    <p:notesMasterId r:id="rId11"/>
   </p:notesMasterIdLst>
   <p:sldIdLst>
     <p:sldId id="256" r:id="rId2"/>
@@ -16,7 +16,7 @@
     <p:sldId id="261" r:id="rId7"/>
     <p:sldId id="262" r:id="rId8"/>
     <p:sldId id="263" r:id="rId9"/>
-    <p:sldId id="264" r:id="rId15"/>
+    <p:sldId id="264" r:id="rId10"/>
   </p:sldIdLst>
   <p:sldSz cx="12192000" cy="6858000"/>
   <p:notesSz cx="6858000" cy="9144000"/>
@@ -3542,7 +3542,7 @@
         </p:nvSpPr>
         <p:spPr>
           <a:xfrm>
-            <a:off x="3662921" y="2217581"/>
+            <a:off x="3662919" y="2878080"/>
             <a:ext cx="4866157" cy="550920"/>
           </a:xfrm>
           <a:prstGeom prst="rect">
@@ -3581,7 +3581,7 @@
         </p:nvSpPr>
         <p:spPr>
           <a:xfrm>
-            <a:off x="4284714" y="3255264"/>
+            <a:off x="4284714" y="3757540"/>
             <a:ext cx="3622569" cy="347472"/>
           </a:xfrm>
           <a:prstGeom prst="rect">
@@ -3723,7 +3723,7 @@
         </p:nvSpPr>
         <p:spPr>
           <a:xfrm>
-            <a:off x="822960" y="1901952"/>
+            <a:off x="822960" y="2377440"/>
             <a:ext cx="384048" cy="292608"/>
           </a:xfrm>
           <a:prstGeom prst="rect">
@@ -3762,7 +3762,7 @@
         </p:nvSpPr>
         <p:spPr>
           <a:xfrm>
-            <a:off x="1335024" y="1901952"/>
+            <a:off x="1335024" y="2377440"/>
             <a:ext cx="2331720" cy="292608"/>
           </a:xfrm>
           <a:prstGeom prst="rect">
@@ -3801,7 +3801,7 @@
         </p:nvSpPr>
         <p:spPr>
           <a:xfrm>
-            <a:off x="3785615" y="1901952"/>
+            <a:off x="3785615" y="2377440"/>
             <a:ext cx="7269480" cy="292608"/>
           </a:xfrm>
           <a:prstGeom prst="rect">
@@ -3840,7 +3840,7 @@
         </p:nvSpPr>
         <p:spPr>
           <a:xfrm>
-            <a:off x="822960" y="2670048"/>
+            <a:off x="822960" y="3145536"/>
             <a:ext cx="384048" cy="292608"/>
           </a:xfrm>
           <a:prstGeom prst="rect">
@@ -3879,7 +3879,7 @@
         </p:nvSpPr>
         <p:spPr>
           <a:xfrm>
-            <a:off x="1335024" y="2670048"/>
+            <a:off x="1335024" y="3145536"/>
             <a:ext cx="2331720" cy="292608"/>
           </a:xfrm>
           <a:prstGeom prst="rect">
@@ -3918,7 +3918,7 @@
         </p:nvSpPr>
         <p:spPr>
           <a:xfrm>
-            <a:off x="3785615" y="2670048"/>
+            <a:off x="3785615" y="3145536"/>
             <a:ext cx="7269480" cy="292608"/>
           </a:xfrm>
           <a:prstGeom prst="rect">
@@ -3957,7 +3957,7 @@
         </p:nvSpPr>
         <p:spPr>
           <a:xfrm>
-            <a:off x="822960" y="3438144"/>
+            <a:off x="822960" y="3913632"/>
             <a:ext cx="384048" cy="292608"/>
           </a:xfrm>
           <a:prstGeom prst="rect">
@@ -3996,7 +3996,7 @@
         </p:nvSpPr>
         <p:spPr>
           <a:xfrm>
-            <a:off x="1335024" y="3438144"/>
+            <a:off x="1335024" y="3913632"/>
             <a:ext cx="2331720" cy="292608"/>
           </a:xfrm>
           <a:prstGeom prst="rect">
@@ -4035,7 +4035,7 @@
         </p:nvSpPr>
         <p:spPr>
           <a:xfrm>
-            <a:off x="3785615" y="3438144"/>
+            <a:off x="3785615" y="3913632"/>
             <a:ext cx="7269480" cy="292608"/>
           </a:xfrm>
           <a:prstGeom prst="rect">
@@ -4074,7 +4074,7 @@
         </p:nvSpPr>
         <p:spPr>
           <a:xfrm>
-            <a:off x="822960" y="4206240"/>
+            <a:off x="822960" y="4681728"/>
             <a:ext cx="384048" cy="292608"/>
           </a:xfrm>
           <a:prstGeom prst="rect">
@@ -4113,7 +4113,7 @@
         </p:nvSpPr>
         <p:spPr>
           <a:xfrm>
-            <a:off x="1335024" y="4206240"/>
+            <a:off x="1335024" y="4681728"/>
             <a:ext cx="2331720" cy="292608"/>
           </a:xfrm>
           <a:prstGeom prst="rect">
@@ -4152,7 +4152,7 @@
         </p:nvSpPr>
         <p:spPr>
           <a:xfrm>
-            <a:off x="3785615" y="4206240"/>
+            <a:off x="3785615" y="4681728"/>
             <a:ext cx="7269480" cy="292608"/>
           </a:xfrm>
           <a:prstGeom prst="rect">
@@ -4179,45 +4179,6 @@
                 <a:latin typeface="Microsoft YaHei"/>
               </a:rPr>
               <a:t>把生成时的迭代搬到训练过程，推理时只保留一次前向。</a:t>
-            </a:r>
-          </a:p>
-        </p:txBody>
-      </p:sp>
-      <p:sp>
-        <p:nvSpPr>
-          <p:cNvPr id="23" name="TextBox 22"/>
-          <p:cNvSpPr txBox="1"/>
-          <p:nvPr/>
-        </p:nvSpPr>
-        <p:spPr>
-          <a:xfrm>
-            <a:off x="960120" y="5362932"/>
-            <a:ext cx="10241280" cy="320088"/>
-          </a:xfrm>
-          <a:prstGeom prst="rect">
-            <a:avLst/>
-          </a:prstGeom>
-          <a:noFill/>
-        </p:spPr>
-        <p:txBody>
-          <a:bodyPr wrap="square" lIns="36576" tIns="36576" rIns="36576" bIns="36576" anchor="ctr">
-            <a:spAutoFit/>
-          </a:bodyPr>
-          <a:lstStyle/>
-          <a:p>
-            <a:pPr algn="ctr">
-              <a:spcAft>
-                <a:spcPts val="0"/>
-              </a:spcAft>
-            </a:pPr>
-            <a:r>
-              <a:rPr sz="1600" b="1">
-                <a:solidFill>
-                  <a:srgbClr val="000000"/>
-                </a:solidFill>
-                <a:latin typeface="Microsoft YaHei"/>
-              </a:rPr>
-              <a:t>路径如何表示、网络学什么、迭代放在哪里。</a:t>
             </a:r>
           </a:p>
         </p:txBody>
@@ -4373,7 +4334,7 @@
         <p:spPr>
           <a:xfrm>
             <a:off x="841248" y="1847088"/>
-            <a:ext cx="3063240" cy="256032"/>
+            <a:ext cx="3063240" cy="369332"/>
           </a:xfrm>
           <a:prstGeom prst="rect">
             <a:avLst/>
@@ -4393,7 +4354,7 @@
               <a:buNone/>
             </a:pPr>
             <a:r>
-              <a:rPr sz="1400" b="1">
+              <a:rPr b="1">
                 <a:solidFill>
                   <a:srgbClr val="000000"/>
                 </a:solidFill>
@@ -4413,7 +4374,7 @@
         <p:spPr>
           <a:xfrm>
             <a:off x="841248" y="2221992"/>
-            <a:ext cx="3063240" cy="1133856"/>
+            <a:ext cx="3063240" cy="830997"/>
           </a:xfrm>
           <a:prstGeom prst="rect">
             <a:avLst/>
@@ -4433,7 +4394,7 @@
               <a:buNone/>
             </a:pPr>
             <a:r>
-              <a:rPr sz="1500">
+              <a:rPr sz="1600">
                 <a:solidFill>
                   <a:srgbClr val="000000"/>
                 </a:solidFill>
@@ -4453,7 +4414,7 @@
         <p:spPr>
           <a:xfrm>
             <a:off x="841248" y="3803904"/>
-            <a:ext cx="3063240" cy="256032"/>
+            <a:ext cx="3063240" cy="369332"/>
           </a:xfrm>
           <a:prstGeom prst="rect">
             <a:avLst/>
@@ -4473,7 +4434,7 @@
               <a:buNone/>
             </a:pPr>
             <a:r>
-              <a:rPr sz="1400" b="1">
+              <a:rPr b="1">
                 <a:solidFill>
                   <a:srgbClr val="000000"/>
                 </a:solidFill>
@@ -4492,8 +4453,8 @@
         </p:nvSpPr>
         <p:spPr>
           <a:xfrm>
-            <a:off x="841248" y="4178808"/>
-            <a:ext cx="3063240" cy="1225296"/>
+            <a:off x="841247" y="4178808"/>
+            <a:ext cx="3267114" cy="1077218"/>
           </a:xfrm>
           <a:prstGeom prst="rect">
             <a:avLst/>
@@ -4513,7 +4474,7 @@
               <a:buNone/>
             </a:pPr>
             <a:r>
-              <a:rPr sz="1500">
+              <a:rPr sz="1600">
                 <a:solidFill>
                   <a:srgbClr val="000000"/>
                 </a:solidFill>
@@ -4533,7 +4494,7 @@
         <p:spPr>
           <a:xfrm>
             <a:off x="4498848" y="1847088"/>
-            <a:ext cx="6537960" cy="256032"/>
+            <a:ext cx="6537960" cy="369332"/>
           </a:xfrm>
           <a:prstGeom prst="rect">
             <a:avLst/>
@@ -4553,7 +4514,7 @@
               <a:buNone/>
             </a:pPr>
             <a:r>
-              <a:rPr sz="1400" b="1">
+              <a:rPr b="1">
                 <a:solidFill>
                   <a:srgbClr val="000000"/>
                 </a:solidFill>
@@ -4572,8 +4533,8 @@
         </p:nvSpPr>
         <p:spPr>
           <a:xfrm>
-            <a:off x="4498848" y="2340864"/>
-            <a:ext cx="6629400" cy="329184"/>
+            <a:off x="4567428" y="2452824"/>
+            <a:ext cx="6851904" cy="338554"/>
           </a:xfrm>
           <a:prstGeom prst="rect">
             <a:avLst/>
@@ -4593,7 +4554,7 @@
               <a:buNone/>
             </a:pPr>
             <a:r>
-              <a:rPr sz="1700" b="1">
+              <a:rPr sz="1600" b="1">
                 <a:solidFill>
                   <a:srgbClr val="000000"/>
                 </a:solidFill>
@@ -4604,41 +4565,6 @@
           </a:p>
         </p:txBody>
       </p:sp>
-      <p:cxnSp>
-        <p:nvCxnSpPr>
-          <p:cNvPr id="41" name="ddpm_flow_rule"/>
-          <p:cNvCxnSpPr/>
-          <p:nvPr/>
-        </p:nvCxnSpPr>
-        <p:spPr>
-          <a:xfrm>
-            <a:off x="4498848" y="2926080"/>
-            <a:ext cx="6611112" cy="0"/>
-          </a:xfrm>
-          <a:prstGeom prst="line">
-            <a:avLst/>
-          </a:prstGeom>
-          <a:ln w="8890">
-            <a:solidFill>
-              <a:srgbClr val="000000"/>
-            </a:solidFill>
-          </a:ln>
-        </p:spPr>
-        <p:style>
-          <a:lnRef idx="2">
-            <a:schemeClr val="accent1"/>
-          </a:lnRef>
-          <a:fillRef idx="0">
-            <a:schemeClr val="accent1"/>
-          </a:fillRef>
-          <a:effectRef idx="1">
-            <a:schemeClr val="accent1"/>
-          </a:effectRef>
-          <a:fontRef idx="minor">
-            <a:schemeClr val="tx1"/>
-          </a:fontRef>
-        </p:style>
-      </p:cxnSp>
       <p:sp>
         <p:nvSpPr>
           <p:cNvPr id="42" name="ddpm_takeaway_title"/>
@@ -4647,8 +4573,8 @@
         </p:nvSpPr>
         <p:spPr>
           <a:xfrm>
-            <a:off x="4498848" y="3291840"/>
-            <a:ext cx="6537960" cy="256032"/>
+            <a:off x="4724400" y="3803904"/>
+            <a:ext cx="6537960" cy="369332"/>
           </a:xfrm>
           <a:prstGeom prst="rect">
             <a:avLst/>
@@ -4668,13 +4594,13 @@
               <a:buNone/>
             </a:pPr>
             <a:r>
-              <a:rPr sz="1400" b="1">
+              <a:rPr b="1">
                 <a:solidFill>
                   <a:srgbClr val="000000"/>
                 </a:solidFill>
                 <a:latin typeface="Microsoft YaHei"/>
               </a:rPr>
-              <a:t>我读懂的关键</a:t>
+              <a:t>关键</a:t>
             </a:r>
           </a:p>
         </p:txBody>
@@ -4687,8 +4613,8 @@
         </p:nvSpPr>
         <p:spPr>
           <a:xfrm>
-            <a:off x="4498848" y="3694176"/>
-            <a:ext cx="6492240" cy="1508760"/>
+            <a:off x="4480560" y="4256650"/>
+            <a:ext cx="6492240" cy="1077218"/>
           </a:xfrm>
           <a:prstGeom prst="rect">
             <a:avLst/>
@@ -4704,46 +4630,30 @@
           </a:bodyPr>
           <a:lstStyle/>
           <a:p>
-            <a:pPr marL="365760" indent="-182880" algn="l">
-              <a:buChar char="•"/>
-            </a:pPr>
-            <a:r>
-              <a:rPr sz="1400">
-                <a:solidFill>
-                  <a:srgbClr val="000000"/>
-                </a:solidFill>
-                <a:latin typeface="Microsoft YaHei"/>
+            <a:pPr marL="182880"/>
+            <a:r>
+              <a:rPr lang="zh-CN" altLang="en-US" sz="1600">
+                <a:latin typeface="微软雅黑" panose="020B0503020204020204" pitchFamily="34" charset="-122"/>
+                <a:ea typeface="微软雅黑" panose="020B0503020204020204" pitchFamily="34" charset="-122"/>
               </a:rPr>
-              <a:t>网络预测噪声，而不是直接预测原图；这种参数化更稳定。</a:t>
-            </a:r>
-          </a:p>
-          <a:p>
-            <a:pPr marL="365760" indent="-182880" algn="l">
-              <a:buChar char="•"/>
-            </a:pPr>
-            <a:r>
-              <a:rPr sz="1400">
-                <a:solidFill>
-                  <a:srgbClr val="000000"/>
-                </a:solidFill>
-                <a:latin typeface="Microsoft YaHei"/>
-              </a:rPr>
-              <a:t>反向方差固定更容易训练，简化目标更关注样本质量。</a:t>
-            </a:r>
-          </a:p>
-          <a:p>
-            <a:pPr marL="365760" indent="-182880" algn="l">
-              <a:buChar char="•"/>
-            </a:pPr>
-            <a:r>
-              <a:rPr sz="1400">
-                <a:solidFill>
-                  <a:srgbClr val="000000"/>
-                </a:solidFill>
-                <a:latin typeface="Microsoft YaHei"/>
-              </a:rPr>
-              <a:t>代价是采样必须走完整条反向链，速度较慢。</a:t>
-            </a:r>
+              <a:t>它先把真实图像逐步加噪到接近纯噪声，再训练网络反向预测每一步噪声并逐步去噪生成图像；特点是训练稳定、机制清楚，是后续扩散模型最重要的工程基线，但推理通常需要很多步</a:t>
+            </a:r>
+            <a:endParaRPr lang="zh-CN" altLang="en-US" sz="1600">
+              <a:solidFill>
+                <a:srgbClr val="000000"/>
+              </a:solidFill>
+              <a:latin typeface="微软雅黑" panose="020B0503020204020204" pitchFamily="34" charset="-122"/>
+              <a:ea typeface="微软雅黑" panose="020B0503020204020204" pitchFamily="34" charset="-122"/>
+            </a:endParaRPr>
+          </a:p>
+          <a:p>
+            <a:pPr marL="182880" algn="l"/>
+            <a:endParaRPr sz="1600">
+              <a:solidFill>
+                <a:srgbClr val="000000"/>
+              </a:solidFill>
+              <a:latin typeface="Microsoft YaHei"/>
+            </a:endParaRPr>
           </a:p>
         </p:txBody>
       </p:sp>
@@ -4774,14 +4684,14 @@
       </p:grpSpPr>
       <p:sp>
         <p:nvSpPr>
-          <p:cNvPr id="2" name="TextBox 1"/>
+          <p:cNvPr id="3" name="TextBox 2"/>
           <p:cNvSpPr txBox="1"/>
           <p:nvPr/>
         </p:nvSpPr>
         <p:spPr>
           <a:xfrm>
-            <a:off x="585216" y="274320"/>
-            <a:ext cx="10972800" cy="201168"/>
+            <a:off x="566928" y="566928"/>
+            <a:ext cx="10972800" cy="420624"/>
           </a:xfrm>
           <a:prstGeom prst="rect">
             <a:avLst/>
@@ -4800,45 +4710,6 @@
               </a:spcAft>
             </a:pPr>
             <a:r>
-              <a:rPr sz="900" b="1">
-                <a:solidFill>
-                  <a:srgbClr val="000000"/>
-                </a:solidFill>
-                <a:latin typeface="Microsoft YaHei"/>
-              </a:rPr>
-              <a:t>03 / 论文二</a:t>
-            </a:r>
-          </a:p>
-        </p:txBody>
-      </p:sp>
-      <p:sp>
-        <p:nvSpPr>
-          <p:cNvPr id="3" name="TextBox 2"/>
-          <p:cNvSpPr txBox="1"/>
-          <p:nvPr/>
-        </p:nvSpPr>
-        <p:spPr>
-          <a:xfrm>
-            <a:off x="566928" y="566928"/>
-            <a:ext cx="10972800" cy="420624"/>
-          </a:xfrm>
-          <a:prstGeom prst="rect">
-            <a:avLst/>
-          </a:prstGeom>
-          <a:noFill/>
-        </p:spPr>
-        <p:txBody>
-          <a:bodyPr wrap="square" lIns="36576" tIns="36576" rIns="36576" bIns="36576" anchor="t">
-            <a:spAutoFit/>
-          </a:bodyPr>
-          <a:lstStyle/>
-          <a:p>
-            <a:pPr algn="l">
-              <a:spcAft>
-                <a:spcPts val="0"/>
-              </a:spcAft>
-            </a:pPr>
-            <a:r>
               <a:rPr sz="2500" b="1">
                 <a:solidFill>
                   <a:srgbClr val="000000"/>
@@ -4898,7 +4769,7 @@
         <p:spPr>
           <a:xfrm>
             <a:off x="841248" y="1847088"/>
-            <a:ext cx="3063240" cy="256032"/>
+            <a:ext cx="3063240" cy="369332"/>
           </a:xfrm>
           <a:prstGeom prst="rect">
             <a:avLst/>
@@ -4918,7 +4789,7 @@
               <a:buNone/>
             </a:pPr>
             <a:r>
-              <a:rPr sz="1400" b="1">
+              <a:rPr b="1">
                 <a:solidFill>
                   <a:srgbClr val="000000"/>
                 </a:solidFill>
@@ -4938,7 +4809,7 @@
         <p:spPr>
           <a:xfrm>
             <a:off x="841248" y="2221992"/>
-            <a:ext cx="3063240" cy="1133856"/>
+            <a:ext cx="3063240" cy="1077218"/>
           </a:xfrm>
           <a:prstGeom prst="rect">
             <a:avLst/>
@@ -4958,7 +4829,7 @@
               <a:buNone/>
             </a:pPr>
             <a:r>
-              <a:rPr sz="1500">
+              <a:rPr sz="1600">
                 <a:solidFill>
                   <a:srgbClr val="000000"/>
                 </a:solidFill>
@@ -4978,7 +4849,7 @@
         <p:spPr>
           <a:xfrm>
             <a:off x="841248" y="3803904"/>
-            <a:ext cx="3063240" cy="256032"/>
+            <a:ext cx="3063240" cy="369332"/>
           </a:xfrm>
           <a:prstGeom prst="rect">
             <a:avLst/>
@@ -4998,7 +4869,7 @@
               <a:buNone/>
             </a:pPr>
             <a:r>
-              <a:rPr sz="1400" b="1">
+              <a:rPr b="1">
                 <a:solidFill>
                   <a:srgbClr val="000000"/>
                 </a:solidFill>
@@ -5018,7 +4889,7 @@
         <p:spPr>
           <a:xfrm>
             <a:off x="841248" y="4178808"/>
-            <a:ext cx="3063240" cy="1225296"/>
+            <a:ext cx="3063240" cy="830997"/>
           </a:xfrm>
           <a:prstGeom prst="rect">
             <a:avLst/>
@@ -5038,7 +4909,7 @@
               <a:buNone/>
             </a:pPr>
             <a:r>
-              <a:rPr sz="1500">
+              <a:rPr sz="1600">
                 <a:solidFill>
                   <a:srgbClr val="000000"/>
                 </a:solidFill>
@@ -5058,7 +4929,7 @@
         <p:spPr>
           <a:xfrm>
             <a:off x="4498848" y="1847088"/>
-            <a:ext cx="6537960" cy="256032"/>
+            <a:ext cx="6537960" cy="369332"/>
           </a:xfrm>
           <a:prstGeom prst="rect">
             <a:avLst/>
@@ -5078,7 +4949,7 @@
               <a:buNone/>
             </a:pPr>
             <a:r>
-              <a:rPr sz="1400" b="1">
+              <a:rPr b="1">
                 <a:solidFill>
                   <a:srgbClr val="000000"/>
                 </a:solidFill>
@@ -5097,8 +4968,8 @@
         </p:nvSpPr>
         <p:spPr>
           <a:xfrm>
-            <a:off x="4498848" y="2340864"/>
-            <a:ext cx="6675120" cy="329184"/>
+            <a:off x="4498848" y="2358926"/>
+            <a:ext cx="6675120" cy="338554"/>
           </a:xfrm>
           <a:prstGeom prst="rect">
             <a:avLst/>
@@ -5118,7 +4989,7 @@
               <a:buNone/>
             </a:pPr>
             <a:r>
-              <a:rPr sz="1700" b="1">
+              <a:rPr sz="1600" b="1">
                 <a:solidFill>
                   <a:srgbClr val="000000"/>
                 </a:solidFill>
@@ -5129,41 +5000,6 @@
           </a:p>
         </p:txBody>
       </p:sp>
-      <p:cxnSp>
-        <p:nvCxnSpPr>
-          <p:cNvPr id="37" name="sde_framework_rule"/>
-          <p:cNvCxnSpPr/>
-          <p:nvPr/>
-        </p:nvCxnSpPr>
-        <p:spPr>
-          <a:xfrm>
-            <a:off x="4498848" y="2926080"/>
-            <a:ext cx="6611112" cy="0"/>
-          </a:xfrm>
-          <a:prstGeom prst="line">
-            <a:avLst/>
-          </a:prstGeom>
-          <a:ln w="8890">
-            <a:solidFill>
-              <a:srgbClr val="000000"/>
-            </a:solidFill>
-          </a:ln>
-        </p:spPr>
-        <p:style>
-          <a:lnRef idx="2">
-            <a:schemeClr val="accent1"/>
-          </a:lnRef>
-          <a:fillRef idx="0">
-            <a:schemeClr val="accent1"/>
-          </a:fillRef>
-          <a:effectRef idx="1">
-            <a:schemeClr val="accent1"/>
-          </a:effectRef>
-          <a:fontRef idx="minor">
-            <a:schemeClr val="tx1"/>
-          </a:fontRef>
-        </p:style>
-      </p:cxnSp>
       <p:sp>
         <p:nvSpPr>
           <p:cNvPr id="38" name="sde_takeaway_title"/>
@@ -5172,8 +5008,8 @@
         </p:nvSpPr>
         <p:spPr>
           <a:xfrm>
-            <a:off x="4498848" y="3291840"/>
-            <a:ext cx="6537960" cy="256032"/>
+            <a:off x="4567428" y="3752159"/>
+            <a:ext cx="6537960" cy="369332"/>
           </a:xfrm>
           <a:prstGeom prst="rect">
             <a:avLst/>
@@ -5193,13 +5029,13 @@
               <a:buNone/>
             </a:pPr>
             <a:r>
-              <a:rPr sz="1400" b="1">
+              <a:rPr b="1">
                 <a:solidFill>
                   <a:srgbClr val="000000"/>
                 </a:solidFill>
                 <a:latin typeface="Microsoft YaHei"/>
               </a:rPr>
-              <a:t>我读懂的关键</a:t>
+              <a:t>关键</a:t>
             </a:r>
           </a:p>
         </p:txBody>
@@ -5212,8 +5048,8 @@
         </p:nvSpPr>
         <p:spPr>
           <a:xfrm>
-            <a:off x="4498848" y="3694176"/>
-            <a:ext cx="6492240" cy="1508760"/>
+            <a:off x="4363620" y="4176747"/>
+            <a:ext cx="6492240" cy="1077218"/>
           </a:xfrm>
           <a:prstGeom prst="rect">
             <a:avLst/>
@@ -5229,46 +5065,35 @@
           </a:bodyPr>
           <a:lstStyle/>
           <a:p>
-            <a:pPr marL="365760" indent="-182880" algn="l">
-              <a:buChar char="•"/>
-            </a:pPr>
-            <a:r>
-              <a:rPr sz="1400">
-                <a:solidFill>
-                  <a:srgbClr val="000000"/>
-                </a:solidFill>
-                <a:latin typeface="Microsoft YaHei"/>
+            <a:pPr marL="182880" algn="l"/>
+            <a:r>
+              <a:rPr lang="zh-CN" altLang="en-US" sz="1600">
+                <a:latin typeface="微软雅黑" panose="020B0503020204020204" pitchFamily="34" charset="-122"/>
+                <a:ea typeface="微软雅黑" panose="020B0503020204020204" pitchFamily="34" charset="-122"/>
               </a:rPr>
-              <a:t>DDPM 可以看作连续框架中的一种离散实现。</a:t>
-            </a:r>
-          </a:p>
-          <a:p>
-            <a:pPr marL="365760" indent="-182880" algn="l">
-              <a:buChar char="•"/>
-            </a:pPr>
-            <a:r>
-              <a:rPr sz="1400">
-                <a:solidFill>
-                  <a:srgbClr val="000000"/>
-                </a:solidFill>
-                <a:latin typeface="Microsoft YaHei"/>
+              <a:t>它把 </a:t>
+            </a:r>
+            <a:r>
+              <a:rPr lang="en-US" altLang="zh-CN" sz="1600">
+                <a:latin typeface="微软雅黑" panose="020B0503020204020204" pitchFamily="34" charset="-122"/>
+                <a:ea typeface="微软雅黑" panose="020B0503020204020204" pitchFamily="34" charset="-122"/>
               </a:rPr>
-              <a:t>不同采样器可在同一分数模型上取舍质量、速度和似然计算。</a:t>
-            </a:r>
-          </a:p>
-          <a:p>
-            <a:pPr marL="365760" indent="-182880" algn="l">
-              <a:buChar char="•"/>
-            </a:pPr>
-            <a:r>
-              <a:rPr sz="1400">
-                <a:solidFill>
-                  <a:srgbClr val="000000"/>
-                </a:solidFill>
-                <a:latin typeface="Microsoft YaHei"/>
+              <a:t>DDPM </a:t>
+            </a:r>
+            <a:r>
+              <a:rPr lang="zh-CN" altLang="en-US" sz="1600">
+                <a:latin typeface="微软雅黑" panose="020B0503020204020204" pitchFamily="34" charset="-122"/>
+                <a:ea typeface="微软雅黑" panose="020B0503020204020204" pitchFamily="34" charset="-122"/>
               </a:rPr>
-              <a:t>条件分数可直接接入修复、补全、着色等成像任务。</a:t>
-            </a:r>
+              <a:t>的离散加噪过程推广为连续时间过程，网络学习不同噪声水平下样本应移动的方向；特点是统一了扩散与分数模型，并可根据质量、速度或似然计算需求选择不同采样器，也方便加入条件约束处理修复、补全等任务。</a:t>
+            </a:r>
+            <a:endParaRPr lang="en-US" sz="1600">
+              <a:solidFill>
+                <a:srgbClr val="000000"/>
+              </a:solidFill>
+              <a:latin typeface="微软雅黑" panose="020B0503020204020204" pitchFamily="34" charset="-122"/>
+              <a:ea typeface="微软雅黑" panose="020B0503020204020204" pitchFamily="34" charset="-122"/>
+            </a:endParaRPr>
           </a:p>
         </p:txBody>
       </p:sp>
@@ -5384,7 +5209,7 @@
         <p:spPr>
           <a:xfrm>
             <a:off x="841248" y="1847088"/>
-            <a:ext cx="3063240" cy="256032"/>
+            <a:ext cx="3063240" cy="369332"/>
           </a:xfrm>
           <a:prstGeom prst="rect">
             <a:avLst/>
@@ -5404,7 +5229,7 @@
               <a:buNone/>
             </a:pPr>
             <a:r>
-              <a:rPr sz="1400" b="1">
+              <a:rPr b="1">
                 <a:solidFill>
                   <a:srgbClr val="000000"/>
                 </a:solidFill>
@@ -5424,7 +5249,7 @@
         <p:spPr>
           <a:xfrm>
             <a:off x="841248" y="2221992"/>
-            <a:ext cx="3063240" cy="1133856"/>
+            <a:ext cx="3063240" cy="830997"/>
           </a:xfrm>
           <a:prstGeom prst="rect">
             <a:avLst/>
@@ -5444,7 +5269,7 @@
               <a:buNone/>
             </a:pPr>
             <a:r>
-              <a:rPr sz="1500">
+              <a:rPr sz="1600">
                 <a:solidFill>
                   <a:srgbClr val="000000"/>
                 </a:solidFill>
@@ -5464,7 +5289,7 @@
         <p:spPr>
           <a:xfrm>
             <a:off x="841248" y="3803904"/>
-            <a:ext cx="3063240" cy="256032"/>
+            <a:ext cx="3063240" cy="369332"/>
           </a:xfrm>
           <a:prstGeom prst="rect">
             <a:avLst/>
@@ -5484,7 +5309,7 @@
               <a:buNone/>
             </a:pPr>
             <a:r>
-              <a:rPr sz="1400" b="1">
+              <a:rPr b="1">
                 <a:solidFill>
                   <a:srgbClr val="000000"/>
                 </a:solidFill>
@@ -5503,8 +5328,8 @@
         </p:nvSpPr>
         <p:spPr>
           <a:xfrm>
-            <a:off x="841248" y="4178808"/>
-            <a:ext cx="3063240" cy="1225296"/>
+            <a:off x="841247" y="4178808"/>
+            <a:ext cx="3286431" cy="830997"/>
           </a:xfrm>
           <a:prstGeom prst="rect">
             <a:avLst/>
@@ -5524,7 +5349,7 @@
               <a:buNone/>
             </a:pPr>
             <a:r>
-              <a:rPr sz="1500">
+              <a:rPr sz="1600">
                 <a:solidFill>
                   <a:srgbClr val="000000"/>
                 </a:solidFill>
@@ -5543,8 +5368,8 @@
         </p:nvSpPr>
         <p:spPr>
           <a:xfrm>
-            <a:off x="4498848" y="1847088"/>
-            <a:ext cx="6537960" cy="256032"/>
+            <a:off x="4498848" y="1813861"/>
+            <a:ext cx="6537960" cy="369332"/>
           </a:xfrm>
           <a:prstGeom prst="rect">
             <a:avLst/>
@@ -5564,7 +5389,7 @@
               <a:buNone/>
             </a:pPr>
             <a:r>
-              <a:rPr sz="1400" b="1">
+              <a:rPr b="1">
                 <a:solidFill>
                   <a:srgbClr val="000000"/>
                 </a:solidFill>
@@ -5581,22 +5406,46 @@
           <p:cNvGraphicFramePr>
             <a:graphicFrameLocks noGrp="1"/>
           </p:cNvGraphicFramePr>
-          <p:nvPr/>
+          <p:nvPr>
+            <p:extLst>
+              <p:ext uri="{D42A27DB-BD31-4B8C-83A1-F6EECF244321}">
+                <p14:modId xmlns:p14="http://schemas.microsoft.com/office/powerpoint/2010/main" val="1450907914"/>
+              </p:ext>
+            </p:extLst>
+          </p:nvPr>
         </p:nvGraphicFramePr>
         <p:xfrm>
-          <a:off x="4498848" y="2267712"/>
+          <a:off x="4595440" y="2203704"/>
           <a:ext cx="6583680" cy="1600200"/>
         </p:xfrm>
         <a:graphic>
           <a:graphicData uri="http://schemas.openxmlformats.org/drawingml/2006/table">
             <a:tbl>
               <a:tblPr>
-                <a:tableStyleId>{5C22544A-7EE6-4342-B048-85BDC9FD1C3A}</a:tableStyleId>
+                <a:tableStyleId>{5940675A-B579-460E-94D1-54222C63F5DA}</a:tableStyleId>
               </a:tblPr>
               <a:tblGrid>
-                <a:gridCol w="960120"/>
-                <a:gridCol w="2788920"/>
-                <a:gridCol w="2834640"/>
+                <a:gridCol w="960120">
+                  <a:extLst>
+                    <a:ext uri="{9D8B030D-6E8A-4147-A177-3AD203B41FA5}">
+                      <a16:colId xmlns:a16="http://schemas.microsoft.com/office/drawing/2014/main" val="20000"/>
+                    </a:ext>
+                  </a:extLst>
+                </a:gridCol>
+                <a:gridCol w="2788920">
+                  <a:extLst>
+                    <a:ext uri="{9D8B030D-6E8A-4147-A177-3AD203B41FA5}">
+                      <a16:colId xmlns:a16="http://schemas.microsoft.com/office/drawing/2014/main" val="20001"/>
+                    </a:ext>
+                  </a:extLst>
+                </a:gridCol>
+                <a:gridCol w="2834640">
+                  <a:extLst>
+                    <a:ext uri="{9D8B030D-6E8A-4147-A177-3AD203B41FA5}">
+                      <a16:colId xmlns:a16="http://schemas.microsoft.com/office/drawing/2014/main" val="20002"/>
+                    </a:ext>
+                  </a:extLst>
+                </a:gridCol>
               </a:tblGrid>
               <a:tr h="533400">
                 <a:tc>
@@ -5608,16 +5457,12 @@
                         <a:buNone/>
                       </a:pPr>
                       <a:r>
-                        <a:rPr b="1" sz="1200"/>
+                        <a:rPr sz="1200" b="1"/>
                         <a:t>比较</a:t>
                       </a:r>
                     </a:p>
                   </a:txBody>
-                  <a:tcPr>
-                    <a:solidFill>
-                      <a:srgbClr val="FFFFFF"/>
-                    </a:solidFill>
-                  </a:tcPr>
+                  <a:tcPr anchor="ctr"/>
                 </a:tc>
                 <a:tc>
                   <a:txBody>
@@ -5628,7 +5473,7 @@
                         <a:buNone/>
                       </a:pPr>
                       <a:r>
-                        <a:rPr b="1" sz="1200">
+                        <a:rPr sz="1200" b="1">
                           <a:solidFill>
                             <a:srgbClr val="000000"/>
                           </a:solidFill>
@@ -5637,11 +5482,7 @@
                       </a:r>
                     </a:p>
                   </a:txBody>
-                  <a:tcPr>
-                    <a:solidFill>
-                      <a:srgbClr val="FFFFFF"/>
-                    </a:solidFill>
-                  </a:tcPr>
+                  <a:tcPr anchor="ctr"/>
                 </a:tc>
                 <a:tc>
                   <a:txBody>
@@ -5652,7 +5493,7 @@
                         <a:buNone/>
                       </a:pPr>
                       <a:r>
-                        <a:rPr b="1" sz="1200">
+                        <a:rPr sz="1200" b="1">
                           <a:solidFill>
                             <a:srgbClr val="000000"/>
                           </a:solidFill>
@@ -5661,12 +5502,13 @@
                       </a:r>
                     </a:p>
                   </a:txBody>
-                  <a:tcPr>
-                    <a:solidFill>
-                      <a:srgbClr val="FFFFFF"/>
-                    </a:solidFill>
-                  </a:tcPr>
+                  <a:tcPr anchor="ctr"/>
                 </a:tc>
+                <a:extLst>
+                  <a:ext uri="{0D108BD9-81ED-4DB2-BD59-A6C34878D82A}">
+                    <a16:rowId xmlns:a16="http://schemas.microsoft.com/office/drawing/2014/main" val="10000"/>
+                  </a:ext>
+                </a:extLst>
               </a:tr>
               <a:tr h="533400">
                 <a:tc>
@@ -5674,6 +5516,7 @@
                     <a:bodyPr/>
                     <a:lstStyle/>
                     <a:p>
+                      <a:pPr algn="ctr"/>
                       <a:r>
                         <a:rPr sz="1200">
                           <a:solidFill>
@@ -5684,17 +5527,14 @@
                       </a:r>
                     </a:p>
                   </a:txBody>
-                  <a:tcPr>
-                    <a:solidFill>
-                      <a:srgbClr val="FFFFFF"/>
-                    </a:solidFill>
-                  </a:tcPr>
+                  <a:tcPr anchor="ctr"/>
                 </a:tc>
                 <a:tc>
                   <a:txBody>
                     <a:bodyPr/>
                     <a:lstStyle/>
                     <a:p>
+                      <a:pPr algn="ctr"/>
                       <a:r>
                         <a:rPr sz="1200">
                           <a:solidFill>
@@ -5705,17 +5545,14 @@
                       </a:r>
                     </a:p>
                   </a:txBody>
-                  <a:tcPr>
-                    <a:solidFill>
-                      <a:srgbClr val="FFFFFF"/>
-                    </a:solidFill>
-                  </a:tcPr>
+                  <a:tcPr anchor="ctr"/>
                 </a:tc>
                 <a:tc>
                   <a:txBody>
                     <a:bodyPr/>
                     <a:lstStyle/>
                     <a:p>
+                      <a:pPr algn="ctr"/>
                       <a:r>
                         <a:rPr sz="1200">
                           <a:solidFill>
@@ -5726,12 +5563,13 @@
                       </a:r>
                     </a:p>
                   </a:txBody>
-                  <a:tcPr>
-                    <a:solidFill>
-                      <a:srgbClr val="FFFFFF"/>
-                    </a:solidFill>
-                  </a:tcPr>
+                  <a:tcPr anchor="ctr"/>
                 </a:tc>
+                <a:extLst>
+                  <a:ext uri="{0D108BD9-81ED-4DB2-BD59-A6C34878D82A}">
+                    <a16:rowId xmlns:a16="http://schemas.microsoft.com/office/drawing/2014/main" val="10001"/>
+                  </a:ext>
+                </a:extLst>
               </a:tr>
               <a:tr h="533400">
                 <a:tc>
@@ -5739,6 +5577,7 @@
                     <a:bodyPr/>
                     <a:lstStyle/>
                     <a:p>
+                      <a:pPr algn="ctr"/>
                       <a:r>
                         <a:rPr sz="1200">
                           <a:solidFill>
@@ -5749,17 +5588,14 @@
                       </a:r>
                     </a:p>
                   </a:txBody>
-                  <a:tcPr>
-                    <a:solidFill>
-                      <a:srgbClr val="FFFFFF"/>
-                    </a:solidFill>
-                  </a:tcPr>
+                  <a:tcPr anchor="ctr"/>
                 </a:tc>
                 <a:tc>
                   <a:txBody>
                     <a:bodyPr/>
                     <a:lstStyle/>
                     <a:p>
+                      <a:pPr algn="ctr"/>
                       <a:r>
                         <a:rPr sz="1200">
                           <a:solidFill>
@@ -5770,17 +5606,14 @@
                       </a:r>
                     </a:p>
                   </a:txBody>
-                  <a:tcPr>
-                    <a:solidFill>
-                      <a:srgbClr val="FFFFFF"/>
-                    </a:solidFill>
-                  </a:tcPr>
+                  <a:tcPr anchor="ctr"/>
                 </a:tc>
                 <a:tc>
                   <a:txBody>
                     <a:bodyPr/>
                     <a:lstStyle/>
                     <a:p>
+                      <a:pPr algn="ctr"/>
                       <a:r>
                         <a:rPr sz="1200">
                           <a:solidFill>
@@ -5791,12 +5624,13 @@
                       </a:r>
                     </a:p>
                   </a:txBody>
-                  <a:tcPr>
-                    <a:solidFill>
-                      <a:srgbClr val="FFFFFF"/>
-                    </a:solidFill>
-                  </a:tcPr>
+                  <a:tcPr anchor="ctr"/>
                 </a:tc>
+                <a:extLst>
+                  <a:ext uri="{0D108BD9-81ED-4DB2-BD59-A6C34878D82A}">
+                    <a16:rowId xmlns:a16="http://schemas.microsoft.com/office/drawing/2014/main" val="10002"/>
+                  </a:ext>
+                </a:extLst>
               </a:tr>
             </a:tbl>
           </a:graphicData>
@@ -5811,7 +5645,7 @@
         <p:spPr>
           <a:xfrm>
             <a:off x="4498848" y="4224528"/>
-            <a:ext cx="6537960" cy="256032"/>
+            <a:ext cx="6537960" cy="369332"/>
           </a:xfrm>
           <a:prstGeom prst="rect">
             <a:avLst/>
@@ -5831,35 +5665,38 @@
               <a:buNone/>
             </a:pPr>
             <a:r>
-              <a:rPr sz="1400" b="1">
+              <a:rPr b="1">
                 <a:solidFill>
                   <a:srgbClr val="000000"/>
                 </a:solidFill>
                 <a:latin typeface="Microsoft YaHei"/>
               </a:rPr>
-              <a:t>我读懂的关键</a:t>
-            </a:r>
-          </a:p>
-        </p:txBody>
-      </p:sp>
-      <p:sp>
-        <p:nvSpPr>
-          <p:cNvPr id="35" name="fm_takeaways"/>
+              <a:t>关键</a:t>
+            </a:r>
+          </a:p>
+        </p:txBody>
+      </p:sp>
+      <p:sp>
+        <p:nvSpPr>
+          <p:cNvPr id="4" name="文本框 3">
+            <a:extLst>
+              <a:ext uri="{FF2B5EF4-FFF2-40B4-BE49-F238E27FC236}">
+                <a16:creationId xmlns:a16="http://schemas.microsoft.com/office/drawing/2014/main" id="{630C2D58-C0B1-EFD2-EA1D-82A98229F438}"/>
+              </a:ext>
+            </a:extLst>
+          </p:cNvPr>
           <p:cNvSpPr txBox="1"/>
           <p:nvPr/>
         </p:nvSpPr>
         <p:spPr>
           <a:xfrm>
-            <a:off x="4498848" y="4599432"/>
-            <a:ext cx="6492240" cy="1115568"/>
+            <a:off x="4498848" y="4655861"/>
+            <a:ext cx="6094926" cy="830997"/>
           </a:xfrm>
           <a:prstGeom prst="rect">
             <a:avLst/>
           </a:prstGeom>
           <a:noFill/>
-          <a:ln>
-            <a:noFill/>
-          </a:ln>
         </p:spPr>
         <p:txBody>
           <a:bodyPr wrap="square">
@@ -5867,45 +5704,26 @@
           </a:bodyPr>
           <a:lstStyle/>
           <a:p>
-            <a:pPr marL="365760" indent="-182880" algn="l">
-              <a:buChar char="•"/>
-            </a:pPr>
-            <a:r>
-              <a:rPr sz="1400">
-                <a:solidFill>
-                  <a:srgbClr val="000000"/>
-                </a:solidFill>
-                <a:latin typeface="Microsoft YaHei"/>
+            <a:r>
+              <a:rPr lang="zh-CN" altLang="en-US" sz="1600">
+                <a:latin typeface="微软雅黑" panose="020B0503020204020204" pitchFamily="34" charset="-122"/>
+                <a:ea typeface="微软雅黑" panose="020B0503020204020204" pitchFamily="34" charset="-122"/>
               </a:rPr>
-              <a:t>网络输出的是速度方向，采样时只需解常微分方程。</a:t>
-            </a:r>
-          </a:p>
-          <a:p>
-            <a:pPr marL="365760" indent="-182880" algn="l">
-              <a:buChar char="•"/>
-            </a:pPr>
-            <a:r>
-              <a:rPr sz="1400">
-                <a:solidFill>
-                  <a:srgbClr val="000000"/>
-                </a:solidFill>
-                <a:latin typeface="Microsoft YaHei"/>
+              <a:t>它不再间接预测分数，而是先指定从噪声到数据的概率路径，再直接回归路径上的速度场；特点是路径可以主动设计，例如使用更直的 </a:t>
+            </a:r>
+            <a:r>
+              <a:rPr lang="en-US" altLang="zh-CN" sz="1600">
+                <a:latin typeface="微软雅黑" panose="020B0503020204020204" pitchFamily="34" charset="-122"/>
+                <a:ea typeface="微软雅黑" panose="020B0503020204020204" pitchFamily="34" charset="-122"/>
               </a:rPr>
-              <a:t>OT 路径降低了向量场的拟合难度，因此能用更少步骤完成采样。</a:t>
-            </a:r>
-          </a:p>
-          <a:p>
-            <a:pPr marL="365760" indent="-182880" algn="l">
-              <a:buChar char="•"/>
-            </a:pPr>
-            <a:r>
-              <a:rPr sz="1400">
-                <a:solidFill>
-                  <a:srgbClr val="000000"/>
-                </a:solidFill>
-                <a:latin typeface="Microsoft YaHei"/>
+              <a:t>OT </a:t>
+            </a:r>
+            <a:r>
+              <a:rPr lang="zh-CN" altLang="en-US" sz="1600">
+                <a:latin typeface="微软雅黑" panose="020B0503020204020204" pitchFamily="34" charset="-122"/>
+                <a:ea typeface="微软雅黑" panose="020B0503020204020204" pitchFamily="34" charset="-122"/>
               </a:rPr>
-              <a:t>优势来自路径和训练目标的设计，不只是换一个采样器。</a:t>
+              <a:t>路径降低拟合难度，从而以更少的采样步数完成高质量生成。</a:t>
             </a:r>
           </a:p>
         </p:txBody>
@@ -6022,7 +5840,7 @@
         <p:spPr>
           <a:xfrm>
             <a:off x="841248" y="1847088"/>
-            <a:ext cx="3063240" cy="256032"/>
+            <a:ext cx="3063240" cy="369332"/>
           </a:xfrm>
           <a:prstGeom prst="rect">
             <a:avLst/>
@@ -6042,7 +5860,7 @@
               <a:buNone/>
             </a:pPr>
             <a:r>
-              <a:rPr sz="1400" b="1">
+              <a:rPr b="1">
                 <a:solidFill>
                   <a:srgbClr val="000000"/>
                 </a:solidFill>
@@ -6061,8 +5879,8 @@
         </p:nvSpPr>
         <p:spPr>
           <a:xfrm>
-            <a:off x="841248" y="2221992"/>
-            <a:ext cx="3063240" cy="1133856"/>
+            <a:off x="744655" y="2331720"/>
+            <a:ext cx="3292871" cy="830997"/>
           </a:xfrm>
           <a:prstGeom prst="rect">
             <a:avLst/>
@@ -6082,7 +5900,7 @@
               <a:buNone/>
             </a:pPr>
             <a:r>
-              <a:rPr sz="1500">
+              <a:rPr sz="1600">
                 <a:solidFill>
                   <a:srgbClr val="000000"/>
                 </a:solidFill>
@@ -6102,7 +5920,7 @@
         <p:spPr>
           <a:xfrm>
             <a:off x="841248" y="3803904"/>
-            <a:ext cx="3063240" cy="256032"/>
+            <a:ext cx="3063240" cy="369332"/>
           </a:xfrm>
           <a:prstGeom prst="rect">
             <a:avLst/>
@@ -6122,7 +5940,7 @@
               <a:buNone/>
             </a:pPr>
             <a:r>
-              <a:rPr sz="1400" b="1">
+              <a:rPr b="1">
                 <a:solidFill>
                   <a:srgbClr val="000000"/>
                 </a:solidFill>
@@ -6142,7 +5960,7 @@
         <p:spPr>
           <a:xfrm>
             <a:off x="841248" y="4178808"/>
-            <a:ext cx="3063240" cy="1225296"/>
+            <a:ext cx="3063240" cy="830997"/>
           </a:xfrm>
           <a:prstGeom prst="rect">
             <a:avLst/>
@@ -6162,7 +5980,7 @@
               <a:buNone/>
             </a:pPr>
             <a:r>
-              <a:rPr sz="1500">
+              <a:rPr sz="1600">
                 <a:solidFill>
                   <a:srgbClr val="000000"/>
                 </a:solidFill>
@@ -6182,7 +6000,7 @@
         <p:spPr>
           <a:xfrm>
             <a:off x="4498848" y="1847088"/>
-            <a:ext cx="6537960" cy="256032"/>
+            <a:ext cx="6537960" cy="369332"/>
           </a:xfrm>
           <a:prstGeom prst="rect">
             <a:avLst/>
@@ -6202,7 +6020,7 @@
               <a:buNone/>
             </a:pPr>
             <a:r>
-              <a:rPr sz="1400" b="1">
+              <a:rPr b="1">
                 <a:solidFill>
                   <a:srgbClr val="000000"/>
                 </a:solidFill>
@@ -6222,7 +6040,7 @@
         <p:spPr>
           <a:xfrm>
             <a:off x="4498848" y="2331720"/>
-            <a:ext cx="6583680" cy="365760"/>
+            <a:ext cx="7068312" cy="338554"/>
           </a:xfrm>
           <a:prstGeom prst="rect">
             <a:avLst/>
@@ -6242,7 +6060,7 @@
               <a:buNone/>
             </a:pPr>
             <a:r>
-              <a:rPr sz="1500" b="1">
+              <a:rPr sz="1600" b="1">
                 <a:solidFill>
                   <a:srgbClr val="000000"/>
                 </a:solidFill>
@@ -6262,7 +6080,7 @@
         <p:spPr>
           <a:xfrm>
             <a:off x="4498848" y="2907792"/>
-            <a:ext cx="6583680" cy="365760"/>
+            <a:ext cx="6583680" cy="338554"/>
           </a:xfrm>
           <a:prstGeom prst="rect">
             <a:avLst/>
@@ -6282,7 +6100,7 @@
               <a:buNone/>
             </a:pPr>
             <a:r>
-              <a:rPr sz="1500" b="1">
+              <a:rPr sz="1600" b="1">
                 <a:solidFill>
                   <a:srgbClr val="000000"/>
                 </a:solidFill>
@@ -6293,41 +6111,6 @@
           </a:p>
         </p:txBody>
       </p:sp>
-      <p:cxnSp>
-        <p:nvCxnSpPr>
-          <p:cNvPr id="38" name="drift_flow_rule"/>
-          <p:cNvCxnSpPr/>
-          <p:nvPr/>
-        </p:nvCxnSpPr>
-        <p:spPr>
-          <a:xfrm>
-            <a:off x="4498848" y="3493008"/>
-            <a:ext cx="6611112" cy="0"/>
-          </a:xfrm>
-          <a:prstGeom prst="line">
-            <a:avLst/>
-          </a:prstGeom>
-          <a:ln w="8890">
-            <a:solidFill>
-              <a:srgbClr val="000000"/>
-            </a:solidFill>
-          </a:ln>
-        </p:spPr>
-        <p:style>
-          <a:lnRef idx="2">
-            <a:schemeClr val="accent1"/>
-          </a:lnRef>
-          <a:fillRef idx="0">
-            <a:schemeClr val="accent1"/>
-          </a:fillRef>
-          <a:effectRef idx="1">
-            <a:schemeClr val="accent1"/>
-          </a:effectRef>
-          <a:fontRef idx="minor">
-            <a:schemeClr val="tx1"/>
-          </a:fontRef>
-        </p:style>
-      </p:cxnSp>
       <p:sp>
         <p:nvSpPr>
           <p:cNvPr id="39" name="drift_takeaway_title"/>
@@ -6336,8 +6119,8 @@
         </p:nvSpPr>
         <p:spPr>
           <a:xfrm>
-            <a:off x="4498848" y="3840480"/>
-            <a:ext cx="6537960" cy="256032"/>
+            <a:off x="4732020" y="3803904"/>
+            <a:ext cx="644910" cy="369332"/>
           </a:xfrm>
           <a:prstGeom prst="rect">
             <a:avLst/>
@@ -6357,13 +6140,13 @@
               <a:buNone/>
             </a:pPr>
             <a:r>
-              <a:rPr sz="1400" b="1">
+              <a:rPr b="1">
                 <a:solidFill>
                   <a:srgbClr val="000000"/>
                 </a:solidFill>
                 <a:latin typeface="Microsoft YaHei"/>
               </a:rPr>
-              <a:t>我读懂的关键</a:t>
+              <a:t>关键</a:t>
             </a:r>
           </a:p>
         </p:txBody>
@@ -6377,7 +6160,7 @@
         <p:spPr>
           <a:xfrm>
             <a:off x="4498848" y="4224528"/>
-            <a:ext cx="6492240" cy="1188720"/>
+            <a:ext cx="6492240" cy="1077218"/>
           </a:xfrm>
           <a:prstGeom prst="rect">
             <a:avLst/>
@@ -6393,46 +6176,21 @@
           </a:bodyPr>
           <a:lstStyle/>
           <a:p>
-            <a:pPr marL="365760" indent="-182880" algn="l">
-              <a:buChar char="•"/>
-            </a:pPr>
-            <a:r>
-              <a:rPr sz="1400">
-                <a:solidFill>
-                  <a:srgbClr val="000000"/>
-                </a:solidFill>
-                <a:latin typeface="Microsoft YaHei"/>
+            <a:pPr marL="182880"/>
+            <a:r>
+              <a:rPr lang="zh-CN" altLang="en-US" sz="1600">
+                <a:latin typeface="微软雅黑" panose="020B0503020204020204" pitchFamily="34" charset="-122"/>
+                <a:ea typeface="微软雅黑" panose="020B0503020204020204" pitchFamily="34" charset="-122"/>
               </a:rPr>
-              <a:t>反对称漂移是平衡条件的关键；破坏它，分布匹配就失效。</a:t>
-            </a:r>
-          </a:p>
-          <a:p>
-            <a:pPr marL="365760" indent="-182880" algn="l">
-              <a:buChar char="•"/>
-            </a:pPr>
-            <a:r>
-              <a:rPr sz="1400">
-                <a:solidFill>
-                  <a:srgbClr val="000000"/>
-                </a:solidFill>
-                <a:latin typeface="Microsoft YaHei"/>
-              </a:rPr>
-              <a:t>冻结漂移后的目标，才能形成稳定的自监督训练。</a:t>
-            </a:r>
-          </a:p>
-          <a:p>
-            <a:pPr marL="365760" indent="-182880" algn="l">
-              <a:buChar char="•"/>
-            </a:pPr>
-            <a:r>
-              <a:rPr sz="1400">
-                <a:solidFill>
-                  <a:srgbClr val="000000"/>
-                </a:solidFill>
-                <a:latin typeface="Microsoft YaHei"/>
-              </a:rPr>
-              <a:t>特征空间漂移和训练时条件引导，是高维图像质量的工程重点。</a:t>
-            </a:r>
+              <a:t>它把传统生成模型在推理阶段进行的多步分布演化提前到训练阶段完成，利用真实样本的吸引和生成样本的排斥推动分布达到平衡；特点是训练完成后可一次前向生成，适合对实时性和推理成本要求很高的场景。</a:t>
+            </a:r>
+            <a:endParaRPr sz="1600">
+              <a:solidFill>
+                <a:srgbClr val="000000"/>
+              </a:solidFill>
+              <a:latin typeface="微软雅黑" panose="020B0503020204020204" pitchFamily="34" charset="-122"/>
+              <a:ea typeface="微软雅黑" panose="020B0503020204020204" pitchFamily="34" charset="-122"/>
+            </a:endParaRPr>
           </a:p>
         </p:txBody>
       </p:sp>
@@ -6470,7 +6228,7 @@
         <p:spPr>
           <a:xfrm>
             <a:off x="566928" y="566928"/>
-            <a:ext cx="10972800" cy="420624"/>
+            <a:ext cx="10972800" cy="458587"/>
           </a:xfrm>
           <a:prstGeom prst="rect">
             <a:avLst/>
@@ -6495,46 +6253,7 @@
                 </a:solidFill>
                 <a:latin typeface="Microsoft YaHei"/>
               </a:rPr>
-              <a:t>四个模型的差异，集中在“迭代放在哪里”</a:t>
-            </a:r>
-          </a:p>
-        </p:txBody>
-      </p:sp>
-      <p:sp>
-        <p:nvSpPr>
-          <p:cNvPr id="4" name="TextBox 3"/>
-          <p:cNvSpPr txBox="1"/>
-          <p:nvPr/>
-        </p:nvSpPr>
-        <p:spPr>
-          <a:xfrm>
-            <a:off x="585216" y="1051560"/>
-            <a:ext cx="10881360" cy="256032"/>
-          </a:xfrm>
-          <a:prstGeom prst="rect">
-            <a:avLst/>
-          </a:prstGeom>
-          <a:noFill/>
-        </p:spPr>
-        <p:txBody>
-          <a:bodyPr wrap="square" lIns="36576" tIns="36576" rIns="36576" bIns="36576" anchor="t">
-            <a:spAutoFit/>
-          </a:bodyPr>
-          <a:lstStyle/>
-          <a:p>
-            <a:pPr algn="l">
-              <a:spcAft>
-                <a:spcPts val="0"/>
-              </a:spcAft>
-            </a:pPr>
-            <a:r>
-              <a:rPr sz="1200" b="0">
-                <a:solidFill>
-                  <a:srgbClr val="000000"/>
-                </a:solidFill>
-                <a:latin typeface="Microsoft YaHei"/>
-              </a:rPr>
-              <a:t>同一条主线下，四篇论文分别优化了表达方式、训练方式和推理成本。</a:t>
+              <a:t>四个模型的差异</a:t>
             </a:r>
           </a:p>
         </p:txBody>
@@ -6584,25 +6303,67 @@
           <p:cNvGraphicFramePr>
             <a:graphicFrameLocks noGrp="1"/>
           </p:cNvGraphicFramePr>
-          <p:nvPr/>
+          <p:nvPr>
+            <p:extLst>
+              <p:ext uri="{D42A27DB-BD31-4B8C-83A1-F6EECF244321}">
+                <p14:modId xmlns:p14="http://schemas.microsoft.com/office/powerpoint/2010/main" val="2622005674"/>
+              </p:ext>
+            </p:extLst>
+          </p:nvPr>
         </p:nvGraphicFramePr>
         <p:xfrm>
-          <a:off x="658368" y="1856231"/>
+          <a:off x="710184" y="1737360"/>
           <a:ext cx="10771631" cy="3383280"/>
         </p:xfrm>
         <a:graphic>
           <a:graphicData uri="http://schemas.openxmlformats.org/drawingml/2006/table">
             <a:tbl>
               <a:tblPr>
-                <a:tableStyleId>{5C22544A-7EE6-4342-B048-85BDC9FD1C3A}</a:tableStyleId>
+                <a:tableStyleId>{5940675A-B579-460E-94D1-54222C63F5DA}</a:tableStyleId>
               </a:tblPr>
               <a:tblGrid>
-                <a:gridCol w="1280160"/>
-                <a:gridCol w="1874519"/>
-                <a:gridCol w="2011680"/>
-                <a:gridCol w="1965960"/>
-                <a:gridCol w="1645920"/>
-                <a:gridCol w="1993392"/>
+                <a:gridCol w="1280160">
+                  <a:extLst>
+                    <a:ext uri="{9D8B030D-6E8A-4147-A177-3AD203B41FA5}">
+                      <a16:colId xmlns:a16="http://schemas.microsoft.com/office/drawing/2014/main" val="20000"/>
+                    </a:ext>
+                  </a:extLst>
+                </a:gridCol>
+                <a:gridCol w="1874519">
+                  <a:extLst>
+                    <a:ext uri="{9D8B030D-6E8A-4147-A177-3AD203B41FA5}">
+                      <a16:colId xmlns:a16="http://schemas.microsoft.com/office/drawing/2014/main" val="20001"/>
+                    </a:ext>
+                  </a:extLst>
+                </a:gridCol>
+                <a:gridCol w="2011680">
+                  <a:extLst>
+                    <a:ext uri="{9D8B030D-6E8A-4147-A177-3AD203B41FA5}">
+                      <a16:colId xmlns:a16="http://schemas.microsoft.com/office/drawing/2014/main" val="20002"/>
+                    </a:ext>
+                  </a:extLst>
+                </a:gridCol>
+                <a:gridCol w="1965960">
+                  <a:extLst>
+                    <a:ext uri="{9D8B030D-6E8A-4147-A177-3AD203B41FA5}">
+                      <a16:colId xmlns:a16="http://schemas.microsoft.com/office/drawing/2014/main" val="20003"/>
+                    </a:ext>
+                  </a:extLst>
+                </a:gridCol>
+                <a:gridCol w="1645920">
+                  <a:extLst>
+                    <a:ext uri="{9D8B030D-6E8A-4147-A177-3AD203B41FA5}">
+                      <a16:colId xmlns:a16="http://schemas.microsoft.com/office/drawing/2014/main" val="20004"/>
+                    </a:ext>
+                  </a:extLst>
+                </a:gridCol>
+                <a:gridCol w="1993392">
+                  <a:extLst>
+                    <a:ext uri="{9D8B030D-6E8A-4147-A177-3AD203B41FA5}">
+                      <a16:colId xmlns:a16="http://schemas.microsoft.com/office/drawing/2014/main" val="20005"/>
+                    </a:ext>
+                  </a:extLst>
+                </a:gridCol>
               </a:tblGrid>
               <a:tr h="676656">
                 <a:tc>
@@ -6614,7 +6375,7 @@
                         <a:buNone/>
                       </a:pPr>
                       <a:r>
-                        <a:rPr b="1" sz="1200">
+                        <a:rPr sz="1200" b="1">
                           <a:solidFill>
                             <a:srgbClr val="000000"/>
                           </a:solidFill>
@@ -6623,11 +6384,7 @@
                       </a:r>
                     </a:p>
                   </a:txBody>
-                  <a:tcPr>
-                    <a:solidFill>
-                      <a:srgbClr val="FFFFFF"/>
-                    </a:solidFill>
-                  </a:tcPr>
+                  <a:tcPr anchor="ctr"/>
                 </a:tc>
                 <a:tc>
                   <a:txBody>
@@ -6638,7 +6395,7 @@
                         <a:buNone/>
                       </a:pPr>
                       <a:r>
-                        <a:rPr b="1" sz="1200">
+                        <a:rPr sz="1200" b="1">
                           <a:solidFill>
                             <a:srgbClr val="000000"/>
                           </a:solidFill>
@@ -6647,11 +6404,7 @@
                       </a:r>
                     </a:p>
                   </a:txBody>
-                  <a:tcPr>
-                    <a:solidFill>
-                      <a:srgbClr val="FFFFFF"/>
-                    </a:solidFill>
-                  </a:tcPr>
+                  <a:tcPr anchor="ctr"/>
                 </a:tc>
                 <a:tc>
                   <a:txBody>
@@ -6662,7 +6415,7 @@
                         <a:buNone/>
                       </a:pPr>
                       <a:r>
-                        <a:rPr b="1" sz="1200">
+                        <a:rPr sz="1200" b="1">
                           <a:solidFill>
                             <a:srgbClr val="000000"/>
                           </a:solidFill>
@@ -6671,11 +6424,7 @@
                       </a:r>
                     </a:p>
                   </a:txBody>
-                  <a:tcPr>
-                    <a:solidFill>
-                      <a:srgbClr val="FFFFFF"/>
-                    </a:solidFill>
-                  </a:tcPr>
+                  <a:tcPr anchor="ctr"/>
                 </a:tc>
                 <a:tc>
                   <a:txBody>
@@ -6686,7 +6435,7 @@
                         <a:buNone/>
                       </a:pPr>
                       <a:r>
-                        <a:rPr b="1" sz="1200">
+                        <a:rPr sz="1200" b="1">
                           <a:solidFill>
                             <a:srgbClr val="000000"/>
                           </a:solidFill>
@@ -6695,11 +6444,7 @@
                       </a:r>
                     </a:p>
                   </a:txBody>
-                  <a:tcPr>
-                    <a:solidFill>
-                      <a:srgbClr val="FFFFFF"/>
-                    </a:solidFill>
-                  </a:tcPr>
+                  <a:tcPr anchor="ctr"/>
                 </a:tc>
                 <a:tc>
                   <a:txBody>
@@ -6710,7 +6455,7 @@
                         <a:buNone/>
                       </a:pPr>
                       <a:r>
-                        <a:rPr b="1" sz="1200">
+                        <a:rPr sz="1200" b="1">
                           <a:solidFill>
                             <a:srgbClr val="000000"/>
                           </a:solidFill>
@@ -6719,11 +6464,7 @@
                       </a:r>
                     </a:p>
                   </a:txBody>
-                  <a:tcPr>
-                    <a:solidFill>
-                      <a:srgbClr val="FFFFFF"/>
-                    </a:solidFill>
-                  </a:tcPr>
+                  <a:tcPr anchor="ctr"/>
                 </a:tc>
                 <a:tc>
                   <a:txBody>
@@ -6734,7 +6475,7 @@
                         <a:buNone/>
                       </a:pPr>
                       <a:r>
-                        <a:rPr b="1" sz="1200">
+                        <a:rPr sz="1200" b="1">
                           <a:solidFill>
                             <a:srgbClr val="000000"/>
                           </a:solidFill>
@@ -6743,12 +6484,13 @@
                       </a:r>
                     </a:p>
                   </a:txBody>
-                  <a:tcPr>
-                    <a:solidFill>
-                      <a:srgbClr val="FFFFFF"/>
-                    </a:solidFill>
-                  </a:tcPr>
+                  <a:tcPr anchor="ctr"/>
                 </a:tc>
+                <a:extLst>
+                  <a:ext uri="{0D108BD9-81ED-4DB2-BD59-A6C34878D82A}">
+                    <a16:rowId xmlns:a16="http://schemas.microsoft.com/office/drawing/2014/main" val="10000"/>
+                  </a:ext>
+                </a:extLst>
               </a:tr>
               <a:tr h="676656">
                 <a:tc>
@@ -6756,8 +6498,9 @@
                     <a:bodyPr/>
                     <a:lstStyle/>
                     <a:p>
+                      <a:pPr algn="ctr"/>
                       <a:r>
-                        <a:rPr sz="1100">
+                        <a:rPr sz="1200">
                           <a:solidFill>
                             <a:srgbClr val="000000"/>
                           </a:solidFill>
@@ -6766,19 +6509,16 @@
                       </a:r>
                     </a:p>
                   </a:txBody>
-                  <a:tcPr>
-                    <a:solidFill>
-                      <a:srgbClr val="FFFFFF"/>
-                    </a:solidFill>
-                  </a:tcPr>
+                  <a:tcPr anchor="ctr"/>
                 </a:tc>
                 <a:tc>
                   <a:txBody>
                     <a:bodyPr/>
                     <a:lstStyle/>
                     <a:p>
+                      <a:pPr algn="ctr"/>
                       <a:r>
-                        <a:rPr sz="1100">
+                        <a:rPr sz="1200">
                           <a:solidFill>
                             <a:srgbClr val="000000"/>
                           </a:solidFill>
@@ -6787,19 +6527,16 @@
                       </a:r>
                     </a:p>
                   </a:txBody>
-                  <a:tcPr>
-                    <a:solidFill>
-                      <a:srgbClr val="FFFFFF"/>
-                    </a:solidFill>
-                  </a:tcPr>
+                  <a:tcPr anchor="ctr"/>
                 </a:tc>
                 <a:tc>
                   <a:txBody>
                     <a:bodyPr/>
                     <a:lstStyle/>
                     <a:p>
+                      <a:pPr algn="ctr"/>
                       <a:r>
-                        <a:rPr sz="1100">
+                        <a:rPr sz="1200">
                           <a:solidFill>
                             <a:srgbClr val="000000"/>
                           </a:solidFill>
@@ -6808,19 +6545,16 @@
                       </a:r>
                     </a:p>
                   </a:txBody>
-                  <a:tcPr>
-                    <a:solidFill>
-                      <a:srgbClr val="FFFFFF"/>
-                    </a:solidFill>
-                  </a:tcPr>
+                  <a:tcPr anchor="ctr"/>
                 </a:tc>
                 <a:tc>
                   <a:txBody>
                     <a:bodyPr/>
                     <a:lstStyle/>
                     <a:p>
+                      <a:pPr algn="ctr"/>
                       <a:r>
-                        <a:rPr sz="1100">
+                        <a:rPr sz="1200">
                           <a:solidFill>
                             <a:srgbClr val="000000"/>
                           </a:solidFill>
@@ -6829,19 +6563,16 @@
                       </a:r>
                     </a:p>
                   </a:txBody>
-                  <a:tcPr>
-                    <a:solidFill>
-                      <a:srgbClr val="FFFFFF"/>
-                    </a:solidFill>
-                  </a:tcPr>
+                  <a:tcPr anchor="ctr"/>
                 </a:tc>
                 <a:tc>
                   <a:txBody>
                     <a:bodyPr/>
                     <a:lstStyle/>
                     <a:p>
+                      <a:pPr algn="ctr"/>
                       <a:r>
-                        <a:rPr sz="1100">
+                        <a:rPr sz="1200">
                           <a:solidFill>
                             <a:srgbClr val="000000"/>
                           </a:solidFill>
@@ -6850,19 +6581,16 @@
                       </a:r>
                     </a:p>
                   </a:txBody>
-                  <a:tcPr>
-                    <a:solidFill>
-                      <a:srgbClr val="FFFFFF"/>
-                    </a:solidFill>
-                  </a:tcPr>
+                  <a:tcPr anchor="ctr"/>
                 </a:tc>
                 <a:tc>
                   <a:txBody>
                     <a:bodyPr/>
                     <a:lstStyle/>
                     <a:p>
+                      <a:pPr algn="ctr"/>
                       <a:r>
-                        <a:rPr sz="1100">
+                        <a:rPr sz="1200">
                           <a:solidFill>
                             <a:srgbClr val="000000"/>
                           </a:solidFill>
@@ -6871,12 +6599,13 @@
                       </a:r>
                     </a:p>
                   </a:txBody>
-                  <a:tcPr>
-                    <a:solidFill>
-                      <a:srgbClr val="FFFFFF"/>
-                    </a:solidFill>
-                  </a:tcPr>
+                  <a:tcPr anchor="ctr"/>
                 </a:tc>
+                <a:extLst>
+                  <a:ext uri="{0D108BD9-81ED-4DB2-BD59-A6C34878D82A}">
+                    <a16:rowId xmlns:a16="http://schemas.microsoft.com/office/drawing/2014/main" val="10001"/>
+                  </a:ext>
+                </a:extLst>
               </a:tr>
               <a:tr h="676656">
                 <a:tc>
@@ -6884,8 +6613,9 @@
                     <a:bodyPr/>
                     <a:lstStyle/>
                     <a:p>
+                      <a:pPr algn="ctr"/>
                       <a:r>
-                        <a:rPr sz="1100">
+                        <a:rPr sz="1200">
                           <a:solidFill>
                             <a:srgbClr val="000000"/>
                           </a:solidFill>
@@ -6894,19 +6624,16 @@
                       </a:r>
                     </a:p>
                   </a:txBody>
-                  <a:tcPr>
-                    <a:solidFill>
-                      <a:srgbClr val="FFFFFF"/>
-                    </a:solidFill>
-                  </a:tcPr>
+                  <a:tcPr anchor="ctr"/>
                 </a:tc>
                 <a:tc>
                   <a:txBody>
                     <a:bodyPr/>
                     <a:lstStyle/>
                     <a:p>
+                      <a:pPr algn="ctr"/>
                       <a:r>
-                        <a:rPr sz="1100">
+                        <a:rPr sz="1200">
                           <a:solidFill>
                             <a:srgbClr val="000000"/>
                           </a:solidFill>
@@ -6915,19 +6642,16 @@
                       </a:r>
                     </a:p>
                   </a:txBody>
-                  <a:tcPr>
-                    <a:solidFill>
-                      <a:srgbClr val="FFFFFF"/>
-                    </a:solidFill>
-                  </a:tcPr>
+                  <a:tcPr anchor="ctr"/>
                 </a:tc>
                 <a:tc>
                   <a:txBody>
                     <a:bodyPr/>
                     <a:lstStyle/>
                     <a:p>
+                      <a:pPr algn="ctr"/>
                       <a:r>
-                        <a:rPr sz="1100">
+                        <a:rPr sz="1200">
                           <a:solidFill>
                             <a:srgbClr val="000000"/>
                           </a:solidFill>
@@ -6936,19 +6660,16 @@
                       </a:r>
                     </a:p>
                   </a:txBody>
-                  <a:tcPr>
-                    <a:solidFill>
-                      <a:srgbClr val="FFFFFF"/>
-                    </a:solidFill>
-                  </a:tcPr>
+                  <a:tcPr anchor="ctr"/>
                 </a:tc>
                 <a:tc>
                   <a:txBody>
                     <a:bodyPr/>
                     <a:lstStyle/>
                     <a:p>
+                      <a:pPr algn="ctr"/>
                       <a:r>
-                        <a:rPr sz="1100">
+                        <a:rPr sz="1200">
                           <a:solidFill>
                             <a:srgbClr val="000000"/>
                           </a:solidFill>
@@ -6957,19 +6678,16 @@
                       </a:r>
                     </a:p>
                   </a:txBody>
-                  <a:tcPr>
-                    <a:solidFill>
-                      <a:srgbClr val="FFFFFF"/>
-                    </a:solidFill>
-                  </a:tcPr>
+                  <a:tcPr anchor="ctr"/>
                 </a:tc>
                 <a:tc>
                   <a:txBody>
                     <a:bodyPr/>
                     <a:lstStyle/>
                     <a:p>
+                      <a:pPr algn="ctr"/>
                       <a:r>
-                        <a:rPr sz="1100">
+                        <a:rPr sz="1200">
                           <a:solidFill>
                             <a:srgbClr val="000000"/>
                           </a:solidFill>
@@ -6978,19 +6696,16 @@
                       </a:r>
                     </a:p>
                   </a:txBody>
-                  <a:tcPr>
-                    <a:solidFill>
-                      <a:srgbClr val="FFFFFF"/>
-                    </a:solidFill>
-                  </a:tcPr>
+                  <a:tcPr anchor="ctr"/>
                 </a:tc>
                 <a:tc>
                   <a:txBody>
                     <a:bodyPr/>
                     <a:lstStyle/>
                     <a:p>
+                      <a:pPr algn="ctr"/>
                       <a:r>
-                        <a:rPr sz="1100">
+                        <a:rPr sz="1200">
                           <a:solidFill>
                             <a:srgbClr val="000000"/>
                           </a:solidFill>
@@ -6999,12 +6714,13 @@
                       </a:r>
                     </a:p>
                   </a:txBody>
-                  <a:tcPr>
-                    <a:solidFill>
-                      <a:srgbClr val="FFFFFF"/>
-                    </a:solidFill>
-                  </a:tcPr>
+                  <a:tcPr anchor="ctr"/>
                 </a:tc>
+                <a:extLst>
+                  <a:ext uri="{0D108BD9-81ED-4DB2-BD59-A6C34878D82A}">
+                    <a16:rowId xmlns:a16="http://schemas.microsoft.com/office/drawing/2014/main" val="10002"/>
+                  </a:ext>
+                </a:extLst>
               </a:tr>
               <a:tr h="676656">
                 <a:tc>
@@ -7012,8 +6728,9 @@
                     <a:bodyPr/>
                     <a:lstStyle/>
                     <a:p>
+                      <a:pPr algn="ctr"/>
                       <a:r>
-                        <a:rPr sz="1100">
+                        <a:rPr sz="1200">
                           <a:solidFill>
                             <a:srgbClr val="000000"/>
                           </a:solidFill>
@@ -7022,19 +6739,16 @@
                       </a:r>
                     </a:p>
                   </a:txBody>
-                  <a:tcPr>
-                    <a:solidFill>
-                      <a:srgbClr val="FFFFFF"/>
-                    </a:solidFill>
-                  </a:tcPr>
+                  <a:tcPr anchor="ctr"/>
                 </a:tc>
                 <a:tc>
                   <a:txBody>
                     <a:bodyPr/>
                     <a:lstStyle/>
                     <a:p>
+                      <a:pPr algn="ctr"/>
                       <a:r>
-                        <a:rPr sz="1100">
+                        <a:rPr sz="1200">
                           <a:solidFill>
                             <a:srgbClr val="000000"/>
                           </a:solidFill>
@@ -7043,19 +6757,16 @@
                       </a:r>
                     </a:p>
                   </a:txBody>
-                  <a:tcPr>
-                    <a:solidFill>
-                      <a:srgbClr val="FFFFFF"/>
-                    </a:solidFill>
-                  </a:tcPr>
+                  <a:tcPr anchor="ctr"/>
                 </a:tc>
                 <a:tc>
                   <a:txBody>
                     <a:bodyPr/>
                     <a:lstStyle/>
                     <a:p>
+                      <a:pPr algn="ctr"/>
                       <a:r>
-                        <a:rPr sz="1100">
+                        <a:rPr sz="1200">
                           <a:solidFill>
                             <a:srgbClr val="000000"/>
                           </a:solidFill>
@@ -7064,19 +6775,16 @@
                       </a:r>
                     </a:p>
                   </a:txBody>
-                  <a:tcPr>
-                    <a:solidFill>
-                      <a:srgbClr val="FFFFFF"/>
-                    </a:solidFill>
-                  </a:tcPr>
+                  <a:tcPr anchor="ctr"/>
                 </a:tc>
                 <a:tc>
                   <a:txBody>
                     <a:bodyPr/>
                     <a:lstStyle/>
                     <a:p>
+                      <a:pPr algn="ctr"/>
                       <a:r>
-                        <a:rPr sz="1100">
+                        <a:rPr sz="1200">
                           <a:solidFill>
                             <a:srgbClr val="000000"/>
                           </a:solidFill>
@@ -7085,19 +6793,16 @@
                       </a:r>
                     </a:p>
                   </a:txBody>
-                  <a:tcPr>
-                    <a:solidFill>
-                      <a:srgbClr val="FFFFFF"/>
-                    </a:solidFill>
-                  </a:tcPr>
+                  <a:tcPr anchor="ctr"/>
                 </a:tc>
                 <a:tc>
                   <a:txBody>
                     <a:bodyPr/>
                     <a:lstStyle/>
                     <a:p>
+                      <a:pPr algn="ctr"/>
                       <a:r>
-                        <a:rPr sz="1100">
+                        <a:rPr sz="1200">
                           <a:solidFill>
                             <a:srgbClr val="000000"/>
                           </a:solidFill>
@@ -7106,19 +6811,16 @@
                       </a:r>
                     </a:p>
                   </a:txBody>
-                  <a:tcPr>
-                    <a:solidFill>
-                      <a:srgbClr val="FFFFFF"/>
-                    </a:solidFill>
-                  </a:tcPr>
+                  <a:tcPr anchor="ctr"/>
                 </a:tc>
                 <a:tc>
                   <a:txBody>
                     <a:bodyPr/>
                     <a:lstStyle/>
                     <a:p>
+                      <a:pPr algn="ctr"/>
                       <a:r>
-                        <a:rPr sz="1100">
+                        <a:rPr sz="1200">
                           <a:solidFill>
                             <a:srgbClr val="000000"/>
                           </a:solidFill>
@@ -7127,12 +6829,13 @@
                       </a:r>
                     </a:p>
                   </a:txBody>
-                  <a:tcPr>
-                    <a:solidFill>
-                      <a:srgbClr val="FFFFFF"/>
-                    </a:solidFill>
-                  </a:tcPr>
+                  <a:tcPr anchor="ctr"/>
                 </a:tc>
+                <a:extLst>
+                  <a:ext uri="{0D108BD9-81ED-4DB2-BD59-A6C34878D82A}">
+                    <a16:rowId xmlns:a16="http://schemas.microsoft.com/office/drawing/2014/main" val="10003"/>
+                  </a:ext>
+                </a:extLst>
               </a:tr>
               <a:tr h="676656">
                 <a:tc>
@@ -7140,8 +6843,9 @@
                     <a:bodyPr/>
                     <a:lstStyle/>
                     <a:p>
+                      <a:pPr algn="ctr"/>
                       <a:r>
-                        <a:rPr sz="1100">
+                        <a:rPr sz="1200">
                           <a:solidFill>
                             <a:srgbClr val="000000"/>
                           </a:solidFill>
@@ -7150,19 +6854,16 @@
                       </a:r>
                     </a:p>
                   </a:txBody>
-                  <a:tcPr>
-                    <a:solidFill>
-                      <a:srgbClr val="FFFFFF"/>
-                    </a:solidFill>
-                  </a:tcPr>
+                  <a:tcPr anchor="ctr"/>
                 </a:tc>
                 <a:tc>
                   <a:txBody>
                     <a:bodyPr/>
                     <a:lstStyle/>
                     <a:p>
+                      <a:pPr algn="ctr"/>
                       <a:r>
-                        <a:rPr sz="1100">
+                        <a:rPr sz="1200">
                           <a:solidFill>
                             <a:srgbClr val="000000"/>
                           </a:solidFill>
@@ -7171,19 +6872,16 @@
                       </a:r>
                     </a:p>
                   </a:txBody>
-                  <a:tcPr>
-                    <a:solidFill>
-                      <a:srgbClr val="FFFFFF"/>
-                    </a:solidFill>
-                  </a:tcPr>
+                  <a:tcPr anchor="ctr"/>
                 </a:tc>
                 <a:tc>
                   <a:txBody>
                     <a:bodyPr/>
                     <a:lstStyle/>
                     <a:p>
+                      <a:pPr algn="ctr"/>
                       <a:r>
-                        <a:rPr sz="1100">
+                        <a:rPr sz="1200">
                           <a:solidFill>
                             <a:srgbClr val="000000"/>
                           </a:solidFill>
@@ -7192,19 +6890,16 @@
                       </a:r>
                     </a:p>
                   </a:txBody>
-                  <a:tcPr>
-                    <a:solidFill>
-                      <a:srgbClr val="FFFFFF"/>
-                    </a:solidFill>
-                  </a:tcPr>
+                  <a:tcPr anchor="ctr"/>
                 </a:tc>
                 <a:tc>
                   <a:txBody>
                     <a:bodyPr/>
                     <a:lstStyle/>
                     <a:p>
+                      <a:pPr algn="ctr"/>
                       <a:r>
-                        <a:rPr sz="1100">
+                        <a:rPr sz="1200">
                           <a:solidFill>
                             <a:srgbClr val="000000"/>
                           </a:solidFill>
@@ -7213,19 +6908,16 @@
                       </a:r>
                     </a:p>
                   </a:txBody>
-                  <a:tcPr>
-                    <a:solidFill>
-                      <a:srgbClr val="FFFFFF"/>
-                    </a:solidFill>
-                  </a:tcPr>
+                  <a:tcPr anchor="ctr"/>
                 </a:tc>
                 <a:tc>
                   <a:txBody>
                     <a:bodyPr/>
                     <a:lstStyle/>
                     <a:p>
+                      <a:pPr algn="ctr"/>
                       <a:r>
-                        <a:rPr sz="1100">
+                        <a:rPr sz="1200">
                           <a:solidFill>
                             <a:srgbClr val="000000"/>
                           </a:solidFill>
@@ -7234,19 +6926,16 @@
                       </a:r>
                     </a:p>
                   </a:txBody>
-                  <a:tcPr>
-                    <a:solidFill>
-                      <a:srgbClr val="FFFFFF"/>
-                    </a:solidFill>
-                  </a:tcPr>
+                  <a:tcPr anchor="ctr"/>
                 </a:tc>
                 <a:tc>
                   <a:txBody>
                     <a:bodyPr/>
                     <a:lstStyle/>
                     <a:p>
+                      <a:pPr algn="ctr"/>
                       <a:r>
-                        <a:rPr sz="1100">
+                        <a:rPr sz="1200">
                           <a:solidFill>
                             <a:srgbClr val="000000"/>
                           </a:solidFill>
@@ -7255,57 +6944,18 @@
                       </a:r>
                     </a:p>
                   </a:txBody>
-                  <a:tcPr>
-                    <a:solidFill>
-                      <a:srgbClr val="FFFFFF"/>
-                    </a:solidFill>
-                  </a:tcPr>
+                  <a:tcPr anchor="ctr"/>
                 </a:tc>
+                <a:extLst>
+                  <a:ext uri="{0D108BD9-81ED-4DB2-BD59-A6C34878D82A}">
+                    <a16:rowId xmlns:a16="http://schemas.microsoft.com/office/drawing/2014/main" val="10004"/>
+                  </a:ext>
+                </a:extLst>
               </a:tr>
             </a:tbl>
           </a:graphicData>
         </a:graphic>
       </p:graphicFrame>
-      <p:sp>
-        <p:nvSpPr>
-          <p:cNvPr id="72" name="comparison_summary"/>
-          <p:cNvSpPr txBox="1"/>
-          <p:nvPr/>
-        </p:nvSpPr>
-        <p:spPr>
-          <a:xfrm>
-            <a:off x="804672" y="5513832"/>
-            <a:ext cx="10469880" cy="292608"/>
-          </a:xfrm>
-          <a:prstGeom prst="rect">
-            <a:avLst/>
-          </a:prstGeom>
-          <a:noFill/>
-          <a:ln>
-            <a:noFill/>
-          </a:ln>
-        </p:spPr>
-        <p:txBody>
-          <a:bodyPr wrap="square">
-            <a:spAutoFit/>
-          </a:bodyPr>
-          <a:lstStyle/>
-          <a:p>
-            <a:pPr marL="0" indent="0">
-              <a:buNone/>
-            </a:pPr>
-            <a:r>
-              <a:rPr sz="1500" b="1">
-                <a:solidFill>
-                  <a:srgbClr val="000000"/>
-                </a:solidFill>
-                <a:latin typeface="Microsoft YaHei"/>
-              </a:rPr>
-              <a:t>演进关系：离散去噪  →  连续分数  →  直接速度回归  →  训练时分布演化</a:t>
-            </a:r>
-          </a:p>
-        </p:txBody>
-      </p:sp>
     </p:spTree>
   </p:cSld>
   <p:clrMapOvr>
@@ -7340,7 +6990,7 @@
         <p:spPr>
           <a:xfrm>
             <a:off x="566928" y="566928"/>
-            <a:ext cx="10972800" cy="420624"/>
+            <a:ext cx="10972800" cy="458587"/>
           </a:xfrm>
           <a:prstGeom prst="rect">
             <a:avLst/>
@@ -7365,155 +7015,7 @@
                 </a:solidFill>
                 <a:latin typeface="Microsoft YaHei"/>
               </a:rPr>
-              <a:t>对多任务成像的启示：先看控制需求，再选生成模型</a:t>
-            </a:r>
-          </a:p>
-        </p:txBody>
-      </p:sp>
-      <p:sp>
-        <p:nvSpPr>
-          <p:cNvPr id="4" name="TextBox 3"/>
-          <p:cNvSpPr txBox="1"/>
-          <p:nvPr/>
-        </p:nvSpPr>
-        <p:spPr>
-          <a:xfrm>
-            <a:off x="585216" y="1051560"/>
-            <a:ext cx="10881360" cy="256032"/>
-          </a:xfrm>
-          <a:prstGeom prst="rect">
-            <a:avLst/>
-          </a:prstGeom>
-          <a:noFill/>
-        </p:spPr>
-        <p:txBody>
-          <a:bodyPr wrap="square" lIns="36576" tIns="36576" rIns="36576" bIns="36576" anchor="t">
-            <a:spAutoFit/>
-          </a:bodyPr>
-          <a:lstStyle/>
-          <a:p>
-            <a:pPr algn="l">
-              <a:spcAft>
-                <a:spcPts val="0"/>
-              </a:spcAft>
-            </a:pPr>
-            <a:r>
-              <a:rPr sz="1200" b="0">
-                <a:solidFill>
-                  <a:srgbClr val="000000"/>
-                </a:solidFill>
-                <a:latin typeface="Microsoft YaHei"/>
-              </a:rPr>
-              <a:t>四种模型不是简单替代关系，而是对应不同的质量、条件控制和推理预算。</a:t>
-            </a:r>
-          </a:p>
-        </p:txBody>
-      </p:sp>
-      <p:cxnSp>
-        <p:nvCxnSpPr>
-          <p:cNvPr id="5" name="Connector 4"/>
-          <p:cNvCxnSpPr/>
-          <p:nvPr/>
-        </p:nvCxnSpPr>
-        <p:spPr>
-          <a:xfrm>
-            <a:off x="566928" y="1481328"/>
-            <a:ext cx="11064240" cy="0"/>
-          </a:xfrm>
-          <a:prstGeom prst="line">
-            <a:avLst/>
-          </a:prstGeom>
-          <a:ln w="10160">
-            <a:solidFill>
-              <a:srgbClr val="000000"/>
-            </a:solidFill>
-          </a:ln>
-        </p:spPr>
-        <p:style>
-          <a:lnRef idx="2">
-            <a:schemeClr val="accent1"/>
-          </a:lnRef>
-          <a:fillRef idx="0">
-            <a:schemeClr val="accent1"/>
-          </a:fillRef>
-          <a:effectRef idx="1">
-            <a:schemeClr val="accent1"/>
-          </a:effectRef>
-          <a:fontRef idx="minor">
-            <a:schemeClr val="tx1"/>
-          </a:fontRef>
-        </p:style>
-      </p:cxnSp>
-      <p:cxnSp>
-        <p:nvCxnSpPr>
-          <p:cNvPr id="48" name="Connector 47"/>
-          <p:cNvCxnSpPr/>
-          <p:nvPr/>
-        </p:nvCxnSpPr>
-        <p:spPr>
-          <a:xfrm>
-            <a:off x="566928" y="6419088"/>
-            <a:ext cx="11064240" cy="0"/>
-          </a:xfrm>
-          <a:prstGeom prst="line">
-            <a:avLst/>
-          </a:prstGeom>
-          <a:ln w="7620">
-            <a:solidFill>
-              <a:srgbClr val="000000"/>
-            </a:solidFill>
-          </a:ln>
-        </p:spPr>
-        <p:style>
-          <a:lnRef idx="2">
-            <a:schemeClr val="accent1"/>
-          </a:lnRef>
-          <a:fillRef idx="0">
-            <a:schemeClr val="accent1"/>
-          </a:fillRef>
-          <a:effectRef idx="1">
-            <a:schemeClr val="accent1"/>
-          </a:effectRef>
-          <a:fontRef idx="minor">
-            <a:schemeClr val="tx1"/>
-          </a:fontRef>
-        </p:style>
-      </p:cxnSp>
-      <p:sp>
-        <p:nvSpPr>
-          <p:cNvPr id="49" name="TextBox 48"/>
-          <p:cNvSpPr txBox="1"/>
-          <p:nvPr/>
-        </p:nvSpPr>
-        <p:spPr>
-          <a:xfrm>
-            <a:off x="585216" y="6473952"/>
-            <a:ext cx="6858000" cy="164592"/>
-          </a:xfrm>
-          <a:prstGeom prst="rect">
-            <a:avLst/>
-          </a:prstGeom>
-          <a:noFill/>
-        </p:spPr>
-        <p:txBody>
-          <a:bodyPr wrap="square" lIns="36576" tIns="36576" rIns="36576" bIns="36576" anchor="t">
-            <a:spAutoFit/>
-          </a:bodyPr>
-          <a:lstStyle/>
-          <a:p>
-            <a:pPr algn="l">
-              <a:spcAft>
-                <a:spcPts val="0"/>
-              </a:spcAft>
-            </a:pPr>
-            <a:r>
-              <a:rPr sz="800" b="0">
-                <a:solidFill>
-                  <a:srgbClr val="000000"/>
-                </a:solidFill>
-                <a:latin typeface="Microsoft YaHei"/>
-              </a:rPr>
-              <a:t>四篇生成模型论文阅读笔记</a:t>
+              <a:t>对多任务成像的启示</a:t>
             </a:r>
           </a:p>
         </p:txBody>
@@ -7563,23 +7065,53 @@
           <p:cNvGraphicFramePr>
             <a:graphicFrameLocks noGrp="1"/>
           </p:cNvGraphicFramePr>
-          <p:nvPr/>
+          <p:nvPr>
+            <p:extLst>
+              <p:ext uri="{D42A27DB-BD31-4B8C-83A1-F6EECF244321}">
+                <p14:modId xmlns:p14="http://schemas.microsoft.com/office/powerpoint/2010/main" val="4243995416"/>
+              </p:ext>
+            </p:extLst>
+          </p:nvPr>
         </p:nvGraphicFramePr>
         <p:xfrm>
-          <a:off x="576072" y="1874519"/>
-          <a:ext cx="10671048" cy="3291840"/>
+          <a:off x="786384" y="1783080"/>
+          <a:ext cx="10533888" cy="3291840"/>
         </p:xfrm>
         <a:graphic>
           <a:graphicData uri="http://schemas.openxmlformats.org/drawingml/2006/table">
             <a:tbl>
               <a:tblPr>
-                <a:tableStyleId>{5C22544A-7EE6-4342-B048-85BDC9FD1C3A}</a:tableStyleId>
+                <a:tableStyleId>{5940675A-B579-460E-94D1-54222C63F5DA}</a:tableStyleId>
               </a:tblPr>
               <a:tblGrid>
-                <a:gridCol w="2057400"/>
-                <a:gridCol w="2286000"/>
-                <a:gridCol w="2743200"/>
-                <a:gridCol w="3447288"/>
+                <a:gridCol w="2057400">
+                  <a:extLst>
+                    <a:ext uri="{9D8B030D-6E8A-4147-A177-3AD203B41FA5}">
+                      <a16:colId xmlns:a16="http://schemas.microsoft.com/office/drawing/2014/main" val="20000"/>
+                    </a:ext>
+                  </a:extLst>
+                </a:gridCol>
+                <a:gridCol w="2286000">
+                  <a:extLst>
+                    <a:ext uri="{9D8B030D-6E8A-4147-A177-3AD203B41FA5}">
+                      <a16:colId xmlns:a16="http://schemas.microsoft.com/office/drawing/2014/main" val="20001"/>
+                    </a:ext>
+                  </a:extLst>
+                </a:gridCol>
+                <a:gridCol w="2743200">
+                  <a:extLst>
+                    <a:ext uri="{9D8B030D-6E8A-4147-A177-3AD203B41FA5}">
+                      <a16:colId xmlns:a16="http://schemas.microsoft.com/office/drawing/2014/main" val="20002"/>
+                    </a:ext>
+                  </a:extLst>
+                </a:gridCol>
+                <a:gridCol w="3447288">
+                  <a:extLst>
+                    <a:ext uri="{9D8B030D-6E8A-4147-A177-3AD203B41FA5}">
+                      <a16:colId xmlns:a16="http://schemas.microsoft.com/office/drawing/2014/main" val="20003"/>
+                    </a:ext>
+                  </a:extLst>
+                </a:gridCol>
               </a:tblGrid>
               <a:tr h="658368">
                 <a:tc>
@@ -7591,7 +7123,7 @@
                         <a:buNone/>
                       </a:pPr>
                       <a:r>
-                        <a:rPr b="1" sz="1200">
+                        <a:rPr sz="1200" b="1">
                           <a:solidFill>
                             <a:srgbClr val="000000"/>
                           </a:solidFill>
@@ -7600,11 +7132,7 @@
                       </a:r>
                     </a:p>
                   </a:txBody>
-                  <a:tcPr>
-                    <a:solidFill>
-                      <a:srgbClr val="FFFFFF"/>
-                    </a:solidFill>
-                  </a:tcPr>
+                  <a:tcPr anchor="ctr"/>
                 </a:tc>
                 <a:tc>
                   <a:txBody>
@@ -7615,7 +7143,7 @@
                         <a:buNone/>
                       </a:pPr>
                       <a:r>
-                        <a:rPr b="1" sz="1200">
+                        <a:rPr sz="1200" b="1">
                           <a:solidFill>
                             <a:srgbClr val="000000"/>
                           </a:solidFill>
@@ -7624,11 +7152,7 @@
                       </a:r>
                     </a:p>
                   </a:txBody>
-                  <a:tcPr>
-                    <a:solidFill>
-                      <a:srgbClr val="FFFFFF"/>
-                    </a:solidFill>
-                  </a:tcPr>
+                  <a:tcPr anchor="ctr"/>
                 </a:tc>
                 <a:tc>
                   <a:txBody>
@@ -7639,7 +7163,7 @@
                         <a:buNone/>
                       </a:pPr>
                       <a:r>
-                        <a:rPr b="1" sz="1200">
+                        <a:rPr sz="1200" b="1">
                           <a:solidFill>
                             <a:srgbClr val="000000"/>
                           </a:solidFill>
@@ -7648,11 +7172,7 @@
                       </a:r>
                     </a:p>
                   </a:txBody>
-                  <a:tcPr>
-                    <a:solidFill>
-                      <a:srgbClr val="FFFFFF"/>
-                    </a:solidFill>
-                  </a:tcPr>
+                  <a:tcPr anchor="ctr"/>
                 </a:tc>
                 <a:tc>
                   <a:txBody>
@@ -7663,7 +7183,7 @@
                         <a:buNone/>
                       </a:pPr>
                       <a:r>
-                        <a:rPr b="1" sz="1200">
+                        <a:rPr sz="1200" b="1">
                           <a:solidFill>
                             <a:srgbClr val="000000"/>
                           </a:solidFill>
@@ -7672,12 +7192,13 @@
                       </a:r>
                     </a:p>
                   </a:txBody>
-                  <a:tcPr>
-                    <a:solidFill>
-                      <a:srgbClr val="FFFFFF"/>
-                    </a:solidFill>
-                  </a:tcPr>
+                  <a:tcPr anchor="ctr"/>
                 </a:tc>
+                <a:extLst>
+                  <a:ext uri="{0D108BD9-81ED-4DB2-BD59-A6C34878D82A}">
+                    <a16:rowId xmlns:a16="http://schemas.microsoft.com/office/drawing/2014/main" val="10000"/>
+                  </a:ext>
+                </a:extLst>
               </a:tr>
               <a:tr h="658368">
                 <a:tc>
@@ -7685,8 +7206,9 @@
                     <a:bodyPr/>
                     <a:lstStyle/>
                     <a:p>
+                      <a:pPr algn="ctr"/>
                       <a:r>
-                        <a:rPr sz="1100">
+                        <a:rPr sz="1200">
                           <a:solidFill>
                             <a:srgbClr val="000000"/>
                           </a:solidFill>
@@ -7695,19 +7217,16 @@
                       </a:r>
                     </a:p>
                   </a:txBody>
-                  <a:tcPr>
-                    <a:solidFill>
-                      <a:srgbClr val="FFFFFF"/>
-                    </a:solidFill>
-                  </a:tcPr>
+                  <a:tcPr anchor="ctr"/>
                 </a:tc>
                 <a:tc>
                   <a:txBody>
                     <a:bodyPr/>
                     <a:lstStyle/>
                     <a:p>
+                      <a:pPr algn="ctr"/>
                       <a:r>
-                        <a:rPr sz="1100">
+                        <a:rPr sz="1200">
                           <a:solidFill>
                             <a:srgbClr val="000000"/>
                           </a:solidFill>
@@ -7716,19 +7235,16 @@
                       </a:r>
                     </a:p>
                   </a:txBody>
-                  <a:tcPr>
-                    <a:solidFill>
-                      <a:srgbClr val="FFFFFF"/>
-                    </a:solidFill>
-                  </a:tcPr>
+                  <a:tcPr anchor="ctr"/>
                 </a:tc>
                 <a:tc>
                   <a:txBody>
                     <a:bodyPr/>
                     <a:lstStyle/>
                     <a:p>
+                      <a:pPr algn="ctr"/>
                       <a:r>
-                        <a:rPr sz="1100">
+                        <a:rPr sz="1200">
                           <a:solidFill>
                             <a:srgbClr val="000000"/>
                           </a:solidFill>
@@ -7737,19 +7253,16 @@
                       </a:r>
                     </a:p>
                   </a:txBody>
-                  <a:tcPr>
-                    <a:solidFill>
-                      <a:srgbClr val="FFFFFF"/>
-                    </a:solidFill>
-                  </a:tcPr>
+                  <a:tcPr anchor="ctr"/>
                 </a:tc>
                 <a:tc>
                   <a:txBody>
                     <a:bodyPr/>
                     <a:lstStyle/>
                     <a:p>
+                      <a:pPr algn="ctr"/>
                       <a:r>
-                        <a:rPr sz="1100">
+                        <a:rPr sz="1200">
                           <a:solidFill>
                             <a:srgbClr val="000000"/>
                           </a:solidFill>
@@ -7758,12 +7271,13 @@
                       </a:r>
                     </a:p>
                   </a:txBody>
-                  <a:tcPr>
-                    <a:solidFill>
-                      <a:srgbClr val="FFFFFF"/>
-                    </a:solidFill>
-                  </a:tcPr>
+                  <a:tcPr anchor="ctr"/>
                 </a:tc>
+                <a:extLst>
+                  <a:ext uri="{0D108BD9-81ED-4DB2-BD59-A6C34878D82A}">
+                    <a16:rowId xmlns:a16="http://schemas.microsoft.com/office/drawing/2014/main" val="10001"/>
+                  </a:ext>
+                </a:extLst>
               </a:tr>
               <a:tr h="658368">
                 <a:tc>
@@ -7771,8 +7285,9 @@
                     <a:bodyPr/>
                     <a:lstStyle/>
                     <a:p>
+                      <a:pPr algn="ctr"/>
                       <a:r>
-                        <a:rPr sz="1100">
+                        <a:rPr sz="1200">
                           <a:solidFill>
                             <a:srgbClr val="000000"/>
                           </a:solidFill>
@@ -7781,19 +7296,16 @@
                       </a:r>
                     </a:p>
                   </a:txBody>
-                  <a:tcPr>
-                    <a:solidFill>
-                      <a:srgbClr val="FFFFFF"/>
-                    </a:solidFill>
-                  </a:tcPr>
+                  <a:tcPr anchor="ctr"/>
                 </a:tc>
                 <a:tc>
                   <a:txBody>
                     <a:bodyPr/>
                     <a:lstStyle/>
                     <a:p>
+                      <a:pPr algn="ctr"/>
                       <a:r>
-                        <a:rPr sz="1100">
+                        <a:rPr sz="1200">
                           <a:solidFill>
                             <a:srgbClr val="000000"/>
                           </a:solidFill>
@@ -7802,19 +7314,16 @@
                       </a:r>
                     </a:p>
                   </a:txBody>
-                  <a:tcPr>
-                    <a:solidFill>
-                      <a:srgbClr val="FFFFFF"/>
-                    </a:solidFill>
-                  </a:tcPr>
+                  <a:tcPr anchor="ctr"/>
                 </a:tc>
                 <a:tc>
                   <a:txBody>
                     <a:bodyPr/>
                     <a:lstStyle/>
                     <a:p>
+                      <a:pPr algn="ctr"/>
                       <a:r>
-                        <a:rPr sz="1100">
+                        <a:rPr sz="1200">
                           <a:solidFill>
                             <a:srgbClr val="000000"/>
                           </a:solidFill>
@@ -7823,19 +7332,16 @@
                       </a:r>
                     </a:p>
                   </a:txBody>
-                  <a:tcPr>
-                    <a:solidFill>
-                      <a:srgbClr val="FFFFFF"/>
-                    </a:solidFill>
-                  </a:tcPr>
+                  <a:tcPr anchor="ctr"/>
                 </a:tc>
                 <a:tc>
                   <a:txBody>
                     <a:bodyPr/>
                     <a:lstStyle/>
                     <a:p>
+                      <a:pPr algn="ctr"/>
                       <a:r>
-                        <a:rPr sz="1100">
+                        <a:rPr sz="1200">
                           <a:solidFill>
                             <a:srgbClr val="000000"/>
                           </a:solidFill>
@@ -7844,12 +7350,13 @@
                       </a:r>
                     </a:p>
                   </a:txBody>
-                  <a:tcPr>
-                    <a:solidFill>
-                      <a:srgbClr val="FFFFFF"/>
-                    </a:solidFill>
-                  </a:tcPr>
+                  <a:tcPr anchor="ctr"/>
                 </a:tc>
+                <a:extLst>
+                  <a:ext uri="{0D108BD9-81ED-4DB2-BD59-A6C34878D82A}">
+                    <a16:rowId xmlns:a16="http://schemas.microsoft.com/office/drawing/2014/main" val="10002"/>
+                  </a:ext>
+                </a:extLst>
               </a:tr>
               <a:tr h="658368">
                 <a:tc>
@@ -7857,8 +7364,9 @@
                     <a:bodyPr/>
                     <a:lstStyle/>
                     <a:p>
+                      <a:pPr algn="ctr"/>
                       <a:r>
-                        <a:rPr sz="1100">
+                        <a:rPr sz="1200">
                           <a:solidFill>
                             <a:srgbClr val="000000"/>
                           </a:solidFill>
@@ -7867,19 +7375,16 @@
                       </a:r>
                     </a:p>
                   </a:txBody>
-                  <a:tcPr>
-                    <a:solidFill>
-                      <a:srgbClr val="FFFFFF"/>
-                    </a:solidFill>
-                  </a:tcPr>
+                  <a:tcPr anchor="ctr"/>
                 </a:tc>
                 <a:tc>
                   <a:txBody>
                     <a:bodyPr/>
                     <a:lstStyle/>
                     <a:p>
+                      <a:pPr algn="ctr"/>
                       <a:r>
-                        <a:rPr sz="1100">
+                        <a:rPr sz="1200">
                           <a:solidFill>
                             <a:srgbClr val="000000"/>
                           </a:solidFill>
@@ -7888,19 +7393,16 @@
                       </a:r>
                     </a:p>
                   </a:txBody>
-                  <a:tcPr>
-                    <a:solidFill>
-                      <a:srgbClr val="FFFFFF"/>
-                    </a:solidFill>
-                  </a:tcPr>
+                  <a:tcPr anchor="ctr"/>
                 </a:tc>
                 <a:tc>
                   <a:txBody>
                     <a:bodyPr/>
                     <a:lstStyle/>
                     <a:p>
+                      <a:pPr algn="ctr"/>
                       <a:r>
-                        <a:rPr sz="1100">
+                        <a:rPr sz="1200">
                           <a:solidFill>
                             <a:srgbClr val="000000"/>
                           </a:solidFill>
@@ -7909,19 +7411,16 @@
                       </a:r>
                     </a:p>
                   </a:txBody>
-                  <a:tcPr>
-                    <a:solidFill>
-                      <a:srgbClr val="FFFFFF"/>
-                    </a:solidFill>
-                  </a:tcPr>
+                  <a:tcPr anchor="ctr"/>
                 </a:tc>
                 <a:tc>
                   <a:txBody>
                     <a:bodyPr/>
                     <a:lstStyle/>
                     <a:p>
+                      <a:pPr algn="ctr"/>
                       <a:r>
-                        <a:rPr sz="1100">
+                        <a:rPr sz="1200">
                           <a:solidFill>
                             <a:srgbClr val="000000"/>
                           </a:solidFill>
@@ -7930,12 +7429,13 @@
                       </a:r>
                     </a:p>
                   </a:txBody>
-                  <a:tcPr>
-                    <a:solidFill>
-                      <a:srgbClr val="FFFFFF"/>
-                    </a:solidFill>
-                  </a:tcPr>
+                  <a:tcPr anchor="ctr"/>
                 </a:tc>
+                <a:extLst>
+                  <a:ext uri="{0D108BD9-81ED-4DB2-BD59-A6C34878D82A}">
+                    <a16:rowId xmlns:a16="http://schemas.microsoft.com/office/drawing/2014/main" val="10003"/>
+                  </a:ext>
+                </a:extLst>
               </a:tr>
               <a:tr h="658368">
                 <a:tc>
@@ -7943,8 +7443,9 @@
                     <a:bodyPr/>
                     <a:lstStyle/>
                     <a:p>
+                      <a:pPr algn="ctr"/>
                       <a:r>
-                        <a:rPr sz="1100">
+                        <a:rPr sz="1200">
                           <a:solidFill>
                             <a:srgbClr val="000000"/>
                           </a:solidFill>
@@ -7953,19 +7454,16 @@
                       </a:r>
                     </a:p>
                   </a:txBody>
-                  <a:tcPr>
-                    <a:solidFill>
-                      <a:srgbClr val="FFFFFF"/>
-                    </a:solidFill>
-                  </a:tcPr>
+                  <a:tcPr anchor="ctr"/>
                 </a:tc>
                 <a:tc>
                   <a:txBody>
                     <a:bodyPr/>
                     <a:lstStyle/>
                     <a:p>
+                      <a:pPr algn="ctr"/>
                       <a:r>
-                        <a:rPr sz="1100">
+                        <a:rPr sz="1200">
                           <a:solidFill>
                             <a:srgbClr val="000000"/>
                           </a:solidFill>
@@ -7974,19 +7472,16 @@
                       </a:r>
                     </a:p>
                   </a:txBody>
-                  <a:tcPr>
-                    <a:solidFill>
-                      <a:srgbClr val="FFFFFF"/>
-                    </a:solidFill>
-                  </a:tcPr>
+                  <a:tcPr anchor="ctr"/>
                 </a:tc>
                 <a:tc>
                   <a:txBody>
                     <a:bodyPr/>
                     <a:lstStyle/>
                     <a:p>
+                      <a:pPr algn="ctr"/>
                       <a:r>
-                        <a:rPr sz="1100">
+                        <a:rPr sz="1200">
                           <a:solidFill>
                             <a:srgbClr val="000000"/>
                           </a:solidFill>
@@ -7995,19 +7490,16 @@
                       </a:r>
                     </a:p>
                   </a:txBody>
-                  <a:tcPr>
-                    <a:solidFill>
-                      <a:srgbClr val="FFFFFF"/>
-                    </a:solidFill>
-                  </a:tcPr>
+                  <a:tcPr anchor="ctr"/>
                 </a:tc>
                 <a:tc>
                   <a:txBody>
                     <a:bodyPr/>
                     <a:lstStyle/>
                     <a:p>
+                      <a:pPr algn="ctr"/>
                       <a:r>
-                        <a:rPr sz="1100">
+                        <a:rPr sz="1200">
                           <a:solidFill>
                             <a:srgbClr val="000000"/>
                           </a:solidFill>
@@ -8016,57 +7508,18 @@
                       </a:r>
                     </a:p>
                   </a:txBody>
-                  <a:tcPr>
-                    <a:solidFill>
-                      <a:srgbClr val="FFFFFF"/>
-                    </a:solidFill>
-                  </a:tcPr>
+                  <a:tcPr anchor="ctr"/>
                 </a:tc>
+                <a:extLst>
+                  <a:ext uri="{0D108BD9-81ED-4DB2-BD59-A6C34878D82A}">
+                    <a16:rowId xmlns:a16="http://schemas.microsoft.com/office/drawing/2014/main" val="10004"/>
+                  </a:ext>
+                </a:extLst>
               </a:tr>
             </a:tbl>
           </a:graphicData>
         </a:graphic>
       </p:graphicFrame>
-      <p:sp>
-        <p:nvSpPr>
-          <p:cNvPr id="52" name="selection_summary"/>
-          <p:cNvSpPr txBox="1"/>
-          <p:nvPr/>
-        </p:nvSpPr>
-        <p:spPr>
-          <a:xfrm>
-            <a:off x="859536" y="5468112"/>
-            <a:ext cx="10149840" cy="292608"/>
-          </a:xfrm>
-          <a:prstGeom prst="rect">
-            <a:avLst/>
-          </a:prstGeom>
-          <a:noFill/>
-          <a:ln>
-            <a:noFill/>
-          </a:ln>
-        </p:spPr>
-        <p:txBody>
-          <a:bodyPr wrap="square">
-            <a:spAutoFit/>
-          </a:bodyPr>
-          <a:lstStyle/>
-          <a:p>
-            <a:pPr marL="0" indent="0">
-              <a:buNone/>
-            </a:pPr>
-            <a:r>
-              <a:rPr sz="1400" b="1">
-                <a:solidFill>
-                  <a:srgbClr val="000000"/>
-                </a:solidFill>
-                <a:latin typeface="Microsoft YaHei"/>
-              </a:rPr>
-              <a:t>建议路线：DDPM 建基线，Score-SDE 做条件控制，Flow Matching 做少步加速，Drifting 做单步探索。</a:t>
-            </a:r>
-          </a:p>
-        </p:txBody>
-      </p:sp>
     </p:spTree>
   </p:cSld>
   <p:clrMapOvr>
@@ -8076,7 +7529,7 @@
 </file>
 
 <file path=ppt/slides/slide9.xml><?xml version="1.0" encoding="utf-8"?>
-<p:sld xmlns:a="http://schemas.openxmlformats.org/drawingml/2006/main" xmlns:p="http://schemas.openxmlformats.org/presentationml/2006/main" xmlns:r="http://schemas.openxmlformats.org/officeDocument/2006/relationships">
+<p:sld xmlns:a="http://schemas.openxmlformats.org/drawingml/2006/main" xmlns:r="http://schemas.openxmlformats.org/officeDocument/2006/relationships" xmlns:p="http://schemas.openxmlformats.org/presentationml/2006/main">
   <p:cSld>
     <p:spTree>
       <p:nvGrpSpPr>
@@ -8084,17 +7537,24 @@
         <p:cNvGrpSpPr/>
         <p:nvPr/>
       </p:nvGrpSpPr>
-      <p:grpSpPr/>
-      <p:sp>
-        <p:nvSpPr>
-          <p:cNvPr id="2" name="summary_section"/>
+      <p:grpSpPr>
+        <a:xfrm>
+          <a:off x="0" y="0"/>
+          <a:ext cx="0" cy="0"/>
+          <a:chOff x="0" y="0"/>
+          <a:chExt cx="0" cy="0"/>
+        </a:xfrm>
+      </p:grpSpPr>
+      <p:sp>
+        <p:nvSpPr>
+          <p:cNvPr id="3" name="summary_title"/>
           <p:cNvSpPr txBox="1"/>
           <p:nvPr/>
         </p:nvSpPr>
         <p:spPr>
           <a:xfrm>
-            <a:off x="585216" y="274320"/>
-            <a:ext cx="10972800" cy="201168"/>
+            <a:off x="565898" y="574161"/>
+            <a:ext cx="10972800" cy="477054"/>
           </a:xfrm>
           <a:prstGeom prst="rect">
             <a:avLst/>
@@ -8114,27 +7574,27 @@
               <a:buNone/>
             </a:pPr>
             <a:r>
-              <a:rPr sz="900" b="1">
+              <a:rPr sz="2500" b="1">
                 <a:solidFill>
                   <a:srgbClr val="000000"/>
                 </a:solidFill>
                 <a:latin typeface="Microsoft YaHei"/>
               </a:rPr>
-              <a:t>09 / 总结</a:t>
-            </a:r>
-          </a:p>
-        </p:txBody>
-      </p:sp>
-      <p:sp>
-        <p:nvSpPr>
-          <p:cNvPr id="3" name="summary_title"/>
+              <a:t>总结</a:t>
+            </a:r>
+          </a:p>
+        </p:txBody>
+      </p:sp>
+      <p:sp>
+        <p:nvSpPr>
+          <p:cNvPr id="6" name="summary_one_number"/>
           <p:cNvSpPr txBox="1"/>
           <p:nvPr/>
         </p:nvSpPr>
         <p:spPr>
           <a:xfrm>
-            <a:off x="566928" y="566928"/>
-            <a:ext cx="10972800" cy="420624"/>
+            <a:off x="822960" y="1975104"/>
+            <a:ext cx="420624" cy="292608"/>
           </a:xfrm>
           <a:prstGeom prst="rect">
             <a:avLst/>
@@ -8154,27 +7614,27 @@
               <a:buNone/>
             </a:pPr>
             <a:r>
-              <a:rPr sz="2500" b="1">
+              <a:rPr sz="1700" b="1">
                 <a:solidFill>
                   <a:srgbClr val="000000"/>
                 </a:solidFill>
                 <a:latin typeface="Microsoft YaHei"/>
               </a:rPr>
-              <a:t>总结：四种模型都在学习如何推动分布</a:t>
-            </a:r>
-          </a:p>
-        </p:txBody>
-      </p:sp>
-      <p:sp>
-        <p:nvSpPr>
-          <p:cNvPr id="4" name="summary_subtitle"/>
+              <a:t>1</a:t>
+            </a:r>
+          </a:p>
+        </p:txBody>
+      </p:sp>
+      <p:sp>
+        <p:nvSpPr>
+          <p:cNvPr id="7" name="summary_one"/>
           <p:cNvSpPr txBox="1"/>
           <p:nvPr/>
         </p:nvSpPr>
         <p:spPr>
           <a:xfrm>
-            <a:off x="585216" y="1051560"/>
-            <a:ext cx="10881360" cy="256032"/>
+            <a:off x="1389888" y="1947672"/>
+            <a:ext cx="9738360" cy="384048"/>
           </a:xfrm>
           <a:prstGeom prst="rect">
             <a:avLst/>
@@ -8194,61 +7654,26 @@
               <a:buNone/>
             </a:pPr>
             <a:r>
-              <a:rPr sz="1200">
+              <a:rPr sz="1600">
                 <a:solidFill>
                   <a:srgbClr val="000000"/>
                 </a:solidFill>
                 <a:latin typeface="Microsoft YaHei"/>
               </a:rPr>
-              <a:t>差异在于路径如何定义、网络学什么局部信息，以及迭代发生在训练还是推理阶段。</a:t>
-            </a:r>
-          </a:p>
-        </p:txBody>
-      </p:sp>
-      <p:cxnSp>
-        <p:nvCxnSpPr>
-          <p:cNvPr id="5" name="summary_header_rule"/>
-          <p:cNvCxnSpPr/>
-          <p:nvPr/>
-        </p:nvCxnSpPr>
-        <p:spPr>
-          <a:xfrm>
-            <a:off x="566928" y="1481328"/>
-            <a:ext cx="11064240" cy="0"/>
-          </a:xfrm>
-          <a:prstGeom prst="line">
-            <a:avLst/>
-          </a:prstGeom>
-          <a:ln w="10160">
-            <a:solidFill>
-              <a:srgbClr val="000000"/>
-            </a:solidFill>
-          </a:ln>
-        </p:spPr>
-        <p:style>
-          <a:lnRef idx="2">
-            <a:schemeClr val="accent1"/>
-          </a:lnRef>
-          <a:fillRef idx="0">
-            <a:schemeClr val="accent1"/>
-          </a:fillRef>
-          <a:effectRef idx="1">
-            <a:schemeClr val="accent1"/>
-          </a:effectRef>
-          <a:fontRef idx="minor">
-            <a:schemeClr val="tx1"/>
-          </a:fontRef>
-        </p:style>
-      </p:cxnSp>
-      <p:sp>
-        <p:nvSpPr>
-          <p:cNvPr id="6" name="summary_one_number"/>
+              <a:t>DDPM 与 Score-SDE 说明：生成可以从逐步去噪走向连续、可控的分布演化。</a:t>
+            </a:r>
+          </a:p>
+        </p:txBody>
+      </p:sp>
+      <p:sp>
+        <p:nvSpPr>
+          <p:cNvPr id="9" name="summary_two_number"/>
           <p:cNvSpPr txBox="1"/>
           <p:nvPr/>
         </p:nvSpPr>
         <p:spPr>
           <a:xfrm>
-            <a:off x="822960" y="1975104"/>
+            <a:off x="822960" y="2971800"/>
             <a:ext cx="420624" cy="292608"/>
           </a:xfrm>
           <a:prstGeom prst="rect">
@@ -8275,20 +7700,20 @@
                 </a:solidFill>
                 <a:latin typeface="Microsoft YaHei"/>
               </a:rPr>
-              <a:t>1</a:t>
-            </a:r>
-          </a:p>
-        </p:txBody>
-      </p:sp>
-      <p:sp>
-        <p:nvSpPr>
-          <p:cNvPr id="7" name="summary_one"/>
+              <a:t>2</a:t>
+            </a:r>
+          </a:p>
+        </p:txBody>
+      </p:sp>
+      <p:sp>
+        <p:nvSpPr>
+          <p:cNvPr id="10" name="summary_two"/>
           <p:cNvSpPr txBox="1"/>
           <p:nvPr/>
         </p:nvSpPr>
         <p:spPr>
           <a:xfrm>
-            <a:off x="1389888" y="1947672"/>
+            <a:off x="1389888" y="2944368"/>
             <a:ext cx="9738360" cy="384048"/>
           </a:xfrm>
           <a:prstGeom prst="rect">
@@ -8315,55 +7740,20 @@
                 </a:solidFill>
                 <a:latin typeface="Microsoft YaHei"/>
               </a:rPr>
-              <a:t>DDPM 与 Score-SDE 说明：生成可以从逐步去噪走向连续、可控的分布演化。</a:t>
-            </a:r>
-          </a:p>
-        </p:txBody>
-      </p:sp>
-      <p:cxnSp>
-        <p:nvCxnSpPr>
-          <p:cNvPr id="8" name="summary_rule_one"/>
-          <p:cNvCxnSpPr/>
-          <p:nvPr/>
-        </p:nvCxnSpPr>
-        <p:spPr>
-          <a:xfrm>
-            <a:off x="822960" y="2606040"/>
-            <a:ext cx="10241280" cy="0"/>
-          </a:xfrm>
-          <a:prstGeom prst="line">
-            <a:avLst/>
-          </a:prstGeom>
-          <a:ln w="6985">
-            <a:solidFill>
-              <a:srgbClr val="000000"/>
-            </a:solidFill>
-          </a:ln>
-        </p:spPr>
-        <p:style>
-          <a:lnRef idx="2">
-            <a:schemeClr val="accent1"/>
-          </a:lnRef>
-          <a:fillRef idx="0">
-            <a:schemeClr val="accent1"/>
-          </a:fillRef>
-          <a:effectRef idx="1">
-            <a:schemeClr val="accent1"/>
-          </a:effectRef>
-          <a:fontRef idx="minor">
-            <a:schemeClr val="tx1"/>
-          </a:fontRef>
-        </p:style>
-      </p:cxnSp>
-      <p:sp>
-        <p:nvSpPr>
-          <p:cNvPr id="9" name="summary_two_number"/>
+              <a:t>Flow Matching 说明：更好的路径设计能降低学习和采样的复杂度。</a:t>
+            </a:r>
+          </a:p>
+        </p:txBody>
+      </p:sp>
+      <p:sp>
+        <p:nvSpPr>
+          <p:cNvPr id="12" name="summary_three_number"/>
           <p:cNvSpPr txBox="1"/>
           <p:nvPr/>
         </p:nvSpPr>
         <p:spPr>
           <a:xfrm>
-            <a:off x="822960" y="2971800"/>
+            <a:off x="822960" y="3968496"/>
             <a:ext cx="420624" cy="292608"/>
           </a:xfrm>
           <a:prstGeom prst="rect">
@@ -8390,20 +7780,20 @@
                 </a:solidFill>
                 <a:latin typeface="Microsoft YaHei"/>
               </a:rPr>
-              <a:t>2</a:t>
-            </a:r>
-          </a:p>
-        </p:txBody>
-      </p:sp>
-      <p:sp>
-        <p:nvSpPr>
-          <p:cNvPr id="10" name="summary_two"/>
+              <a:t>3</a:t>
+            </a:r>
+          </a:p>
+        </p:txBody>
+      </p:sp>
+      <p:sp>
+        <p:nvSpPr>
+          <p:cNvPr id="13" name="summary_three"/>
           <p:cNvSpPr txBox="1"/>
           <p:nvPr/>
         </p:nvSpPr>
         <p:spPr>
           <a:xfrm>
-            <a:off x="1389888" y="2944368"/>
+            <a:off x="1389888" y="3941063"/>
             <a:ext cx="9738360" cy="384048"/>
           </a:xfrm>
           <a:prstGeom prst="rect">
@@ -8430,56 +7820,21 @@
                 </a:solidFill>
                 <a:latin typeface="Microsoft YaHei"/>
               </a:rPr>
-              <a:t>Flow Matching 说明：更好的路径设计能降低学习和采样的复杂度。</a:t>
-            </a:r>
-          </a:p>
-        </p:txBody>
-      </p:sp>
-      <p:cxnSp>
-        <p:nvCxnSpPr>
-          <p:cNvPr id="11" name="summary_rule_two"/>
-          <p:cNvCxnSpPr/>
-          <p:nvPr/>
-        </p:nvCxnSpPr>
-        <p:spPr>
-          <a:xfrm>
-            <a:off x="822960" y="3602736"/>
-            <a:ext cx="10241280" cy="0"/>
-          </a:xfrm>
-          <a:prstGeom prst="line">
-            <a:avLst/>
-          </a:prstGeom>
-          <a:ln w="6985">
-            <a:solidFill>
-              <a:srgbClr val="000000"/>
-            </a:solidFill>
-          </a:ln>
-        </p:spPr>
-        <p:style>
-          <a:lnRef idx="2">
-            <a:schemeClr val="accent1"/>
-          </a:lnRef>
-          <a:fillRef idx="0">
-            <a:schemeClr val="accent1"/>
-          </a:fillRef>
-          <a:effectRef idx="1">
-            <a:schemeClr val="accent1"/>
-          </a:effectRef>
-          <a:fontRef idx="minor">
-            <a:schemeClr val="tx1"/>
-          </a:fontRef>
-        </p:style>
-      </p:cxnSp>
-      <p:sp>
-        <p:nvSpPr>
-          <p:cNvPr id="12" name="summary_three_number"/>
+              <a:t>Drifting 说明：极致推理效率可以通过把分布演化提前到训练阶段来实现。</a:t>
+            </a:r>
+          </a:p>
+        </p:txBody>
+      </p:sp>
+      <p:sp>
+        <p:nvSpPr>
+          <p:cNvPr id="15" name="summary_final"/>
           <p:cNvSpPr txBox="1"/>
           <p:nvPr/>
         </p:nvSpPr>
         <p:spPr>
           <a:xfrm>
-            <a:off x="822960" y="3968496"/>
-            <a:ext cx="420624" cy="292608"/>
+            <a:off x="822960" y="5148072"/>
+            <a:ext cx="10332720" cy="329184"/>
           </a:xfrm>
           <a:prstGeom prst="rect">
             <a:avLst/>
@@ -8499,121 +7854,6 @@
               <a:buNone/>
             </a:pPr>
             <a:r>
-              <a:rPr sz="1700" b="1">
-                <a:solidFill>
-                  <a:srgbClr val="000000"/>
-                </a:solidFill>
-                <a:latin typeface="Microsoft YaHei"/>
-              </a:rPr>
-              <a:t>3</a:t>
-            </a:r>
-          </a:p>
-        </p:txBody>
-      </p:sp>
-      <p:sp>
-        <p:nvSpPr>
-          <p:cNvPr id="13" name="summary_three"/>
-          <p:cNvSpPr txBox="1"/>
-          <p:nvPr/>
-        </p:nvSpPr>
-        <p:spPr>
-          <a:xfrm>
-            <a:off x="1389888" y="3941063"/>
-            <a:ext cx="9738360" cy="384048"/>
-          </a:xfrm>
-          <a:prstGeom prst="rect">
-            <a:avLst/>
-          </a:prstGeom>
-          <a:noFill/>
-          <a:ln>
-            <a:noFill/>
-          </a:ln>
-        </p:spPr>
-        <p:txBody>
-          <a:bodyPr wrap="square">
-            <a:spAutoFit/>
-          </a:bodyPr>
-          <a:lstStyle/>
-          <a:p>
-            <a:pPr marL="0" indent="0">
-              <a:buNone/>
-            </a:pPr>
-            <a:r>
-              <a:rPr sz="1600">
-                <a:solidFill>
-                  <a:srgbClr val="000000"/>
-                </a:solidFill>
-                <a:latin typeface="Microsoft YaHei"/>
-              </a:rPr>
-              <a:t>Drifting 说明：极致推理效率可以通过把分布演化提前到训练阶段来实现。</a:t>
-            </a:r>
-          </a:p>
-        </p:txBody>
-      </p:sp>
-      <p:cxnSp>
-        <p:nvCxnSpPr>
-          <p:cNvPr id="14" name="summary_rule_three"/>
-          <p:cNvCxnSpPr/>
-          <p:nvPr/>
-        </p:nvCxnSpPr>
-        <p:spPr>
-          <a:xfrm>
-            <a:off x="822960" y="4599432"/>
-            <a:ext cx="10241280" cy="0"/>
-          </a:xfrm>
-          <a:prstGeom prst="line">
-            <a:avLst/>
-          </a:prstGeom>
-          <a:ln w="6985">
-            <a:solidFill>
-              <a:srgbClr val="000000"/>
-            </a:solidFill>
-          </a:ln>
-        </p:spPr>
-        <p:style>
-          <a:lnRef idx="2">
-            <a:schemeClr val="accent1"/>
-          </a:lnRef>
-          <a:fillRef idx="0">
-            <a:schemeClr val="accent1"/>
-          </a:fillRef>
-          <a:effectRef idx="1">
-            <a:schemeClr val="accent1"/>
-          </a:effectRef>
-          <a:fontRef idx="minor">
-            <a:schemeClr val="tx1"/>
-          </a:fontRef>
-        </p:style>
-      </p:cxnSp>
-      <p:sp>
-        <p:nvSpPr>
-          <p:cNvPr id="15" name="summary_final"/>
-          <p:cNvSpPr txBox="1"/>
-          <p:nvPr/>
-        </p:nvSpPr>
-        <p:spPr>
-          <a:xfrm>
-            <a:off x="822960" y="5148072"/>
-            <a:ext cx="10332720" cy="329184"/>
-          </a:xfrm>
-          <a:prstGeom prst="rect">
-            <a:avLst/>
-          </a:prstGeom>
-          <a:noFill/>
-          <a:ln>
-            <a:noFill/>
-          </a:ln>
-        </p:spPr>
-        <p:txBody>
-          <a:bodyPr wrap="square">
-            <a:spAutoFit/>
-          </a:bodyPr>
-          <a:lstStyle/>
-          <a:p>
-            <a:pPr marL="0" indent="0">
-              <a:buNone/>
-            </a:pPr>
-            <a:r>
               <a:rPr sz="1600" b="1">
                 <a:solidFill>
                   <a:srgbClr val="000000"/>
@@ -8621,81 +7861,6 @@
                 <a:latin typeface="Microsoft YaHei"/>
               </a:rPr>
               <a:t>对多任务成像：先确定条件控制、质量和时延的优先级，再选择对应的生成路径。</a:t>
-            </a:r>
-          </a:p>
-        </p:txBody>
-      </p:sp>
-      <p:cxnSp>
-        <p:nvCxnSpPr>
-          <p:cNvPr id="16" name="summary_footer_rule"/>
-          <p:cNvCxnSpPr/>
-          <p:nvPr/>
-        </p:nvCxnSpPr>
-        <p:spPr>
-          <a:xfrm>
-            <a:off x="566928" y="6419088"/>
-            <a:ext cx="11064240" cy="0"/>
-          </a:xfrm>
-          <a:prstGeom prst="line">
-            <a:avLst/>
-          </a:prstGeom>
-          <a:ln w="7620">
-            <a:solidFill>
-              <a:srgbClr val="000000"/>
-            </a:solidFill>
-          </a:ln>
-        </p:spPr>
-        <p:style>
-          <a:lnRef idx="2">
-            <a:schemeClr val="accent1"/>
-          </a:lnRef>
-          <a:fillRef idx="0">
-            <a:schemeClr val="accent1"/>
-          </a:fillRef>
-          <a:effectRef idx="1">
-            <a:schemeClr val="accent1"/>
-          </a:effectRef>
-          <a:fontRef idx="minor">
-            <a:schemeClr val="tx1"/>
-          </a:fontRef>
-        </p:style>
-      </p:cxnSp>
-      <p:sp>
-        <p:nvSpPr>
-          <p:cNvPr id="17" name="summary_footer_source"/>
-          <p:cNvSpPr txBox="1"/>
-          <p:nvPr/>
-        </p:nvSpPr>
-        <p:spPr>
-          <a:xfrm>
-            <a:off x="585216" y="6473952"/>
-            <a:ext cx="6858000" cy="164592"/>
-          </a:xfrm>
-          <a:prstGeom prst="rect">
-            <a:avLst/>
-          </a:prstGeom>
-          <a:noFill/>
-          <a:ln>
-            <a:noFill/>
-          </a:ln>
-        </p:spPr>
-        <p:txBody>
-          <a:bodyPr wrap="square">
-            <a:spAutoFit/>
-          </a:bodyPr>
-          <a:lstStyle/>
-          <a:p>
-            <a:pPr marL="0" indent="0">
-              <a:buNone/>
-            </a:pPr>
-            <a:r>
-              <a:rPr sz="800">
-                <a:solidFill>
-                  <a:srgbClr val="000000"/>
-                </a:solidFill>
-                <a:latin typeface="Microsoft YaHei"/>
-              </a:rPr>
-              <a:t>四篇生成模型论文阅读笔记</a:t>
             </a:r>
           </a:p>
         </p:txBody>

</xml_diff>